<commit_message>
fix(presentation): generate reference-grade management reports
</commit_message>
<xml_diff>
--- a/golden-data/expected/sales-pilot-v1.pptx
+++ b/golden-data/expected/sales-pilot-v1.pptx
@@ -593,7 +593,8 @@
           <a:p>
             <a:r>
               <a:rPr lang="en-US" dirty="0"/>
-              <a:t>指标由授权 XLSX 来源确定性复算。</a:t>
+              <a:t>指标由授权 XLSX 来源确定性复算。
+Evidence: ev-pilot-task-total, ev-pilot-current-total, ev-pilot-prior-total, ev-pilot-performance</a:t>
             </a:r>
             <a:endParaRPr lang="en-US" dirty="0"/>
           </a:p>
@@ -681,7 +682,8 @@
           <a:p>
             <a:r>
               <a:rPr lang="en-US" dirty="0"/>
-              <a:t>仅显示 deterministic aliases，不包含真实姓名。</a:t>
+              <a:t>仅显示 deterministic aliases，不包含真实姓名。
+Evidence: ev-pilot-current-total, ev-pilot-prior-total, ev-pilot-performance</a:t>
             </a:r>
             <a:endParaRPr lang="en-US" dirty="0"/>
           </a:p>
@@ -769,7 +771,8 @@
           <a:p>
             <a:r>
               <a:rPr lang="en-US" dirty="0"/>
-              <a:t>该结论仅用于单样本回归，不扩大为业务质量认证。</a:t>
+              <a:t>该结论仅用于单样本回归，不扩大为业务质量认证。
+Evidence: ev-pilot-performance</a:t>
             </a:r>
             <a:endParaRPr lang="en-US" dirty="0"/>
           </a:p>
@@ -847,7 +850,7 @@
     <p:bg>
       <p:bgPr>
         <a:solidFill>
-          <a:srgbClr val="F8F7F3"/>
+          <a:srgbClr val="FBF9F6"/>
         </a:solidFill>
       </p:bgPr>
     </p:bg>
@@ -880,11 +883,11 @@
             <a:avLst/>
           </a:prstGeom>
           <a:solidFill>
-            <a:srgbClr val="24443A"/>
+            <a:srgbClr val="8B1E1E"/>
           </a:solidFill>
           <a:ln w="12700">
             <a:solidFill>
-              <a:srgbClr val="24443A">
+              <a:srgbClr val="8B1E1E">
                 <a:alpha val="0"/>
               </a:srgbClr>
             </a:solidFill>
@@ -918,7 +921,7 @@
               <a:buNone/>
               <a:defRPr lang="en-US" sz="3000" b="1" dirty="0">
                 <a:solidFill>
-                  <a:srgbClr val="24443A"/>
+                  <a:srgbClr val="8B1E1E"/>
                 </a:solidFill>
                 <a:latin typeface="Microsoft YaHei" pitchFamily="34" charset="0"/>
                 <a:ea typeface="Microsoft YaHei" pitchFamily="34" charset="-122"/>
@@ -960,7 +963,7 @@
               <a:buNone/>
               <a:defRPr lang="en-US" sz="1800" dirty="0">
                 <a:solidFill>
-                  <a:srgbClr val="1F2A27"/>
+                  <a:srgbClr val="2B211F"/>
                 </a:solidFill>
                 <a:latin typeface="Microsoft YaHei" pitchFamily="34" charset="0"/>
                 <a:ea typeface="Microsoft YaHei" pitchFamily="34" charset="-122"/>
@@ -1003,7 +1006,7 @@
             <a:r>
               <a:rPr lang="en-US" sz="800" dirty="0">
                 <a:solidFill>
-                  <a:srgbClr val="6D7D77"/>
+                  <a:srgbClr val="7D6C68"/>
                 </a:solidFill>
                 <a:latin typeface="Microsoft YaHei" pitchFamily="34" charset="0"/>
                 <a:ea typeface="Microsoft YaHei" pitchFamily="34" charset="-122"/>
@@ -1045,7 +1048,7 @@
             <a:lvl1pPr>
               <a:defRPr sz="900">
                 <a:solidFill>
-                  <a:srgbClr val="6D7D77"/>
+                  <a:srgbClr val="7D6C68"/>
                 </a:solidFill>
                 <a:latin typeface="Microsoft YaHei"/>
                 <a:ea typeface="Microsoft YaHei"/>
@@ -1077,7 +1080,7 @@
     <p:bg>
       <p:bgPr>
         <a:solidFill>
-          <a:srgbClr val="F8F7F3"/>
+          <a:srgbClr val="FBF9F6"/>
         </a:solidFill>
       </p:bgPr>
     </p:bg>
@@ -1110,11 +1113,11 @@
             <a:avLst/>
           </a:prstGeom>
           <a:solidFill>
-            <a:srgbClr val="24443A"/>
+            <a:srgbClr val="8B1E1E"/>
           </a:solidFill>
           <a:ln w="12700">
             <a:solidFill>
-              <a:srgbClr val="24443A">
+              <a:srgbClr val="8B1E1E">
                 <a:alpha val="0"/>
               </a:srgbClr>
             </a:solidFill>
@@ -1148,7 +1151,7 @@
               <a:buNone/>
               <a:defRPr lang="en-US" sz="2400" b="1" dirty="0">
                 <a:solidFill>
-                  <a:srgbClr val="24443A"/>
+                  <a:srgbClr val="8B1E1E"/>
                 </a:solidFill>
                 <a:latin typeface="Microsoft YaHei" pitchFamily="34" charset="0"/>
                 <a:ea typeface="Microsoft YaHei" pitchFamily="34" charset="-122"/>
@@ -1190,7 +1193,7 @@
               <a:buNone/>
               <a:defRPr lang="en-US" sz="1800" dirty="0">
                 <a:solidFill>
-                  <a:srgbClr val="1F2A27"/>
+                  <a:srgbClr val="2B211F"/>
                 </a:solidFill>
                 <a:latin typeface="Microsoft YaHei" pitchFamily="34" charset="0"/>
                 <a:ea typeface="Microsoft YaHei" pitchFamily="34" charset="-122"/>
@@ -1233,7 +1236,7 @@
             <a:r>
               <a:rPr lang="en-US" sz="800" dirty="0">
                 <a:solidFill>
-                  <a:srgbClr val="6D7D77"/>
+                  <a:srgbClr val="7D6C68"/>
                 </a:solidFill>
                 <a:latin typeface="Microsoft YaHei" pitchFamily="34" charset="0"/>
                 <a:ea typeface="Microsoft YaHei" pitchFamily="34" charset="-122"/>
@@ -1275,7 +1278,7 @@
             <a:lvl1pPr>
               <a:defRPr sz="900">
                 <a:solidFill>
-                  <a:srgbClr val="6D7D77"/>
+                  <a:srgbClr val="7D6C68"/>
                 </a:solidFill>
                 <a:latin typeface="Microsoft YaHei"/>
                 <a:ea typeface="Microsoft YaHei"/>
@@ -1307,7 +1310,7 @@
     <p:bg>
       <p:bgPr>
         <a:solidFill>
-          <a:srgbClr val="F8F7F3"/>
+          <a:srgbClr val="FBF9F6"/>
         </a:solidFill>
       </p:bgPr>
     </p:bg>
@@ -1340,11 +1343,11 @@
             <a:avLst/>
           </a:prstGeom>
           <a:solidFill>
-            <a:srgbClr val="24443A"/>
+            <a:srgbClr val="8B1E1E"/>
           </a:solidFill>
           <a:ln w="12700">
             <a:solidFill>
-              <a:srgbClr val="24443A">
+              <a:srgbClr val="8B1E1E">
                 <a:alpha val="0"/>
               </a:srgbClr>
             </a:solidFill>
@@ -1378,7 +1381,7 @@
               <a:buNone/>
               <a:defRPr lang="en-US" sz="3000" b="1" dirty="0">
                 <a:solidFill>
-                  <a:srgbClr val="24443A"/>
+                  <a:srgbClr val="8B1E1E"/>
                 </a:solidFill>
                 <a:latin typeface="Microsoft YaHei" pitchFamily="34" charset="0"/>
                 <a:ea typeface="Microsoft YaHei" pitchFamily="34" charset="-122"/>
@@ -1420,7 +1423,7 @@
               <a:buNone/>
               <a:defRPr lang="en-US" sz="1800" dirty="0">
                 <a:solidFill>
-                  <a:srgbClr val="1F2A27"/>
+                  <a:srgbClr val="2B211F"/>
                 </a:solidFill>
                 <a:latin typeface="Microsoft YaHei" pitchFamily="34" charset="0"/>
                 <a:ea typeface="Microsoft YaHei" pitchFamily="34" charset="-122"/>
@@ -1463,7 +1466,7 @@
             <a:r>
               <a:rPr lang="en-US" sz="800" dirty="0">
                 <a:solidFill>
-                  <a:srgbClr val="6D7D77"/>
+                  <a:srgbClr val="7D6C68"/>
                 </a:solidFill>
                 <a:latin typeface="Microsoft YaHei" pitchFamily="34" charset="0"/>
                 <a:ea typeface="Microsoft YaHei" pitchFamily="34" charset="-122"/>
@@ -1505,7 +1508,7 @@
             <a:lvl1pPr>
               <a:defRPr sz="900">
                 <a:solidFill>
-                  <a:srgbClr val="6D7D77"/>
+                  <a:srgbClr val="7D6C68"/>
                 </a:solidFill>
                 <a:latin typeface="Microsoft YaHei"/>
                 <a:ea typeface="Microsoft YaHei"/>
@@ -1537,7 +1540,7 @@
     <p:bg>
       <p:bgPr>
         <a:solidFill>
-          <a:srgbClr val="F8F7F3"/>
+          <a:srgbClr val="FBF9F6"/>
         </a:solidFill>
       </p:bgPr>
     </p:bg>
@@ -1570,11 +1573,11 @@
             <a:avLst/>
           </a:prstGeom>
           <a:solidFill>
-            <a:srgbClr val="24443A"/>
+            <a:srgbClr val="8B1E1E"/>
           </a:solidFill>
           <a:ln w="12700">
             <a:solidFill>
-              <a:srgbClr val="24443A">
+              <a:srgbClr val="8B1E1E">
                 <a:alpha val="0"/>
               </a:srgbClr>
             </a:solidFill>
@@ -1608,7 +1611,7 @@
               <a:buNone/>
               <a:defRPr lang="en-US" sz="3000" b="1" dirty="0">
                 <a:solidFill>
-                  <a:srgbClr val="24443A"/>
+                  <a:srgbClr val="8B1E1E"/>
                 </a:solidFill>
                 <a:latin typeface="Microsoft YaHei" pitchFamily="34" charset="0"/>
                 <a:ea typeface="Microsoft YaHei" pitchFamily="34" charset="-122"/>
@@ -1650,7 +1653,7 @@
               <a:buNone/>
               <a:defRPr lang="en-US" sz="1800" dirty="0">
                 <a:solidFill>
-                  <a:srgbClr val="1F2A27"/>
+                  <a:srgbClr val="2B211F"/>
                 </a:solidFill>
                 <a:latin typeface="Microsoft YaHei" pitchFamily="34" charset="0"/>
                 <a:ea typeface="Microsoft YaHei" pitchFamily="34" charset="-122"/>
@@ -1693,7 +1696,7 @@
             <a:r>
               <a:rPr lang="en-US" sz="800" dirty="0">
                 <a:solidFill>
-                  <a:srgbClr val="6D7D77"/>
+                  <a:srgbClr val="7D6C68"/>
                 </a:solidFill>
                 <a:latin typeface="Microsoft YaHei" pitchFamily="34" charset="0"/>
                 <a:ea typeface="Microsoft YaHei" pitchFamily="34" charset="-122"/>
@@ -1735,7 +1738,7 @@
             <a:lvl1pPr>
               <a:defRPr sz="900">
                 <a:solidFill>
-                  <a:srgbClr val="6D7D77"/>
+                  <a:srgbClr val="7D6C68"/>
                 </a:solidFill>
                 <a:latin typeface="Microsoft YaHei"/>
                 <a:ea typeface="Microsoft YaHei"/>
@@ -1808,7 +1811,7 @@
             <a:lvl1pPr>
               <a:defRPr sz="900">
                 <a:solidFill>
-                  <a:srgbClr val="6D7D77"/>
+                  <a:srgbClr val="7D6C68"/>
                 </a:solidFill>
                 <a:latin typeface="Microsoft YaHei"/>
                 <a:ea typeface="Microsoft YaHei"/>
@@ -2136,7 +2139,7 @@
             <a:r>
               <a:rPr lang="en-US" sz="3000" b="1" dirty="0">
                 <a:solidFill>
-                  <a:srgbClr val="24443A"/>
+                  <a:srgbClr val="8B1E1E"/>
                 </a:solidFill>
                 <a:latin typeface="Microsoft YaHei" pitchFamily="34" charset="0"/>
                 <a:ea typeface="Microsoft YaHei" pitchFamily="34" charset="-122"/>
@@ -2175,7 +2178,7 @@
             <a:r>
               <a:rPr lang="en-US" sz="1800" dirty="0">
                 <a:solidFill>
-                  <a:srgbClr val="6D7D77"/>
+                  <a:srgbClr val="7D6C68"/>
                 </a:solidFill>
                 <a:latin typeface="Microsoft YaHei" pitchFamily="34" charset="0"/>
                 <a:ea typeface="Microsoft YaHei" pitchFamily="34" charset="-122"/>
@@ -2247,7 +2250,7 @@
             <a:lvl1pPr>
               <a:defRPr sz="900">
                 <a:solidFill>
-                  <a:srgbClr val="6D7D77"/>
+                  <a:srgbClr val="7D6C68"/>
                 </a:solidFill>
                 <a:latin typeface="Microsoft YaHei"/>
                 <a:ea typeface="Microsoft YaHei"/>
@@ -2319,7 +2322,7 @@
             <a:r>
               <a:rPr lang="en-US" sz="2400" b="1" dirty="0">
                 <a:solidFill>
-                  <a:srgbClr val="24443A"/>
+                  <a:srgbClr val="8B1E1E"/>
                 </a:solidFill>
                 <a:latin typeface="Microsoft YaHei" pitchFamily="34" charset="0"/>
                 <a:ea typeface="Microsoft YaHei" pitchFamily="34" charset="-122"/>
@@ -2422,7 +2425,7 @@
                       <a:tailEnd type="none" w="med" len="med"/>
                     </a:lnB>
                     <a:solidFill>
-                      <a:srgbClr val="24443A"/>
+                      <a:srgbClr val="8B1E1E"/>
                     </a:solidFill>
                   </a:tcPr>
                 </a:tc>
@@ -2490,7 +2493,7 @@
                       <a:tailEnd type="none" w="med" len="med"/>
                     </a:lnB>
                     <a:solidFill>
-                      <a:srgbClr val="24443A"/>
+                      <a:srgbClr val="8B1E1E"/>
                     </a:solidFill>
                   </a:tcPr>
                 </a:tc>
@@ -2505,9 +2508,9 @@
                         <a:buNone/>
                       </a:pPr>
                       <a:r>
-                        <a:rPr lang="en-US" sz="1100" dirty="0">
+                        <a:rPr lang="en-US" sz="1100" b="1" dirty="0">
                           <a:solidFill>
-                            <a:srgbClr val="1F2A27"/>
+                            <a:srgbClr val="2B211F"/>
                           </a:solidFill>
                           <a:latin typeface="Microsoft YaHei" pitchFamily="34" charset="0"/>
                           <a:ea typeface="Microsoft YaHei" pitchFamily="34" charset="-122"/>
@@ -2575,7 +2578,7 @@
                       <a:r>
                         <a:rPr lang="en-US" sz="1100" dirty="0">
                           <a:solidFill>
-                            <a:srgbClr val="1F2A27"/>
+                            <a:srgbClr val="2B211F"/>
                           </a:solidFill>
                           <a:latin typeface="Microsoft YaHei" pitchFamily="34" charset="0"/>
                           <a:ea typeface="Microsoft YaHei" pitchFamily="34" charset="-122"/>
@@ -2643,15 +2646,153 @@
                         <a:buNone/>
                       </a:pPr>
                       <a:r>
-                        <a:rPr lang="en-US" sz="1100" dirty="0">
+                        <a:rPr lang="en-US" sz="1100" b="1" dirty="0">
                           <a:solidFill>
-                            <a:srgbClr val="1F2A27"/>
+                            <a:srgbClr val="2B211F"/>
                           </a:solidFill>
                           <a:latin typeface="Microsoft YaHei" pitchFamily="34" charset="0"/>
                           <a:ea typeface="Microsoft YaHei" pitchFamily="34" charset="-122"/>
                           <a:cs typeface="Microsoft YaHei" pitchFamily="34" charset="-120"/>
                         </a:rPr>
                         <a:t>本期出货</a:t>
+                      </a:r>
+                      <a:endParaRPr lang="en-US" sz="1100" dirty="0">
+                        <a:latin typeface="Microsoft YaHei" charset="0"/>
+                        <a:ea typeface="Microsoft YaHei" charset="0"/>
+                        <a:cs typeface="Microsoft YaHei" charset="0"/>
+                      </a:endParaRPr>
+                    </a:p>
+                  </a:txBody>
+                  <a:tcPr marL="38100" marR="38100" marT="38100" marB="38100">
+                    <a:lnL w="6350" cap="flat" cmpd="sng" algn="ctr">
+                      <a:solidFill>
+                        <a:srgbClr val="D8DEE8"/>
+                      </a:solidFill>
+                      <a:prstDash val="solid"/>
+                      <a:round/>
+                      <a:headEnd type="none" w="med" len="med"/>
+                      <a:tailEnd type="none" w="med" len="med"/>
+                    </a:lnL>
+                    <a:lnR w="6350" cap="flat" cmpd="sng" algn="ctr">
+                      <a:solidFill>
+                        <a:srgbClr val="D8DEE8"/>
+                      </a:solidFill>
+                      <a:prstDash val="solid"/>
+                      <a:round/>
+                      <a:headEnd type="none" w="med" len="med"/>
+                      <a:tailEnd type="none" w="med" len="med"/>
+                    </a:lnR>
+                    <a:lnT w="6350" cap="flat" cmpd="sng" algn="ctr">
+                      <a:solidFill>
+                        <a:srgbClr val="D8DEE8"/>
+                      </a:solidFill>
+                      <a:prstDash val="solid"/>
+                      <a:round/>
+                      <a:headEnd type="none" w="med" len="med"/>
+                      <a:tailEnd type="none" w="med" len="med"/>
+                    </a:lnT>
+                    <a:lnB w="6350" cap="flat" cmpd="sng" algn="ctr">
+                      <a:solidFill>
+                        <a:srgbClr val="D8DEE8"/>
+                      </a:solidFill>
+                      <a:prstDash val="solid"/>
+                      <a:round/>
+                      <a:headEnd type="none" w="med" len="med"/>
+                      <a:tailEnd type="none" w="med" len="med"/>
+                    </a:lnB>
+                    <a:solidFill>
+                      <a:srgbClr val="FBF9F6"/>
+                    </a:solidFill>
+                  </a:tcPr>
+                </a:tc>
+                <a:tc>
+                  <a:txBody>
+                    <a:bodyPr/>
+                    <a:lstStyle/>
+                    <a:p>
+                      <a:pPr indent="0" marL="0">
+                        <a:buNone/>
+                      </a:pPr>
+                      <a:r>
+                        <a:rPr lang="en-US" sz="1100" dirty="0">
+                          <a:solidFill>
+                            <a:srgbClr val="2B211F"/>
+                          </a:solidFill>
+                          <a:latin typeface="Microsoft YaHei" pitchFamily="34" charset="0"/>
+                          <a:ea typeface="Microsoft YaHei" pitchFamily="34" charset="-122"/>
+                          <a:cs typeface="Microsoft YaHei" pitchFamily="34" charset="-120"/>
+                        </a:rPr>
+                        <a:t>119692</a:t>
+                      </a:r>
+                      <a:endParaRPr lang="en-US" sz="1100" dirty="0">
+                        <a:latin typeface="Microsoft YaHei" charset="0"/>
+                        <a:ea typeface="Microsoft YaHei" charset="0"/>
+                        <a:cs typeface="Microsoft YaHei" charset="0"/>
+                      </a:endParaRPr>
+                    </a:p>
+                  </a:txBody>
+                  <a:tcPr marL="38100" marR="38100" marT="38100" marB="38100">
+                    <a:lnL w="6350" cap="flat" cmpd="sng" algn="ctr">
+                      <a:solidFill>
+                        <a:srgbClr val="D8DEE8"/>
+                      </a:solidFill>
+                      <a:prstDash val="solid"/>
+                      <a:round/>
+                      <a:headEnd type="none" w="med" len="med"/>
+                      <a:tailEnd type="none" w="med" len="med"/>
+                    </a:lnL>
+                    <a:lnR w="6350" cap="flat" cmpd="sng" algn="ctr">
+                      <a:solidFill>
+                        <a:srgbClr val="D8DEE8"/>
+                      </a:solidFill>
+                      <a:prstDash val="solid"/>
+                      <a:round/>
+                      <a:headEnd type="none" w="med" len="med"/>
+                      <a:tailEnd type="none" w="med" len="med"/>
+                    </a:lnR>
+                    <a:lnT w="6350" cap="flat" cmpd="sng" algn="ctr">
+                      <a:solidFill>
+                        <a:srgbClr val="D8DEE8"/>
+                      </a:solidFill>
+                      <a:prstDash val="solid"/>
+                      <a:round/>
+                      <a:headEnd type="none" w="med" len="med"/>
+                      <a:tailEnd type="none" w="med" len="med"/>
+                    </a:lnT>
+                    <a:lnB w="6350" cap="flat" cmpd="sng" algn="ctr">
+                      <a:solidFill>
+                        <a:srgbClr val="D8DEE8"/>
+                      </a:solidFill>
+                      <a:prstDash val="solid"/>
+                      <a:round/>
+                      <a:headEnd type="none" w="med" len="med"/>
+                      <a:tailEnd type="none" w="med" len="med"/>
+                    </a:lnB>
+                    <a:solidFill>
+                      <a:srgbClr val="FBF9F6"/>
+                    </a:solidFill>
+                  </a:tcPr>
+                </a:tc>
+              </a:tr>
+              <a:tr h="563880">
+                <a:tc>
+                  <a:txBody>
+                    <a:bodyPr/>
+                    <a:lstStyle/>
+                    <a:p>
+                      <a:pPr indent="0" marL="0">
+                        <a:buNone/>
+                      </a:pPr>
+                      <a:r>
+                        <a:rPr lang="en-US" sz="1100" b="1" dirty="0">
+                          <a:solidFill>
+                            <a:srgbClr val="2B211F"/>
+                          </a:solidFill>
+                          <a:latin typeface="Microsoft YaHei" pitchFamily="34" charset="0"/>
+                          <a:ea typeface="Microsoft YaHei" pitchFamily="34" charset="-122"/>
+                          <a:cs typeface="Microsoft YaHei" pitchFamily="34" charset="-120"/>
+                        </a:rPr>
+                        <a:t>上年同期</a:t>
                       </a:r>
                       <a:endParaRPr lang="en-US" sz="1100" dirty="0">
                         <a:latin typeface="Microsoft YaHei" charset="0"/>
@@ -2713,13 +2854,13 @@
                       <a:r>
                         <a:rPr lang="en-US" sz="1100" dirty="0">
                           <a:solidFill>
-                            <a:srgbClr val="1F2A27"/>
+                            <a:srgbClr val="2B211F"/>
                           </a:solidFill>
                           <a:latin typeface="Microsoft YaHei" pitchFamily="34" charset="0"/>
                           <a:ea typeface="Microsoft YaHei" pitchFamily="34" charset="-122"/>
                           <a:cs typeface="Microsoft YaHei" pitchFamily="34" charset="-120"/>
                         </a:rPr>
-                        <a:t>119692</a:t>
+                        <a:t>104383.6</a:t>
                       </a:r>
                       <a:endParaRPr lang="en-US" sz="1100" dirty="0">
                         <a:latin typeface="Microsoft YaHei" charset="0"/>
@@ -2781,15 +2922,153 @@
                         <a:buNone/>
                       </a:pPr>
                       <a:r>
-                        <a:rPr lang="en-US" sz="1100" dirty="0">
+                        <a:rPr lang="en-US" sz="1100" b="1" dirty="0">
                           <a:solidFill>
-                            <a:srgbClr val="1F2A27"/>
+                            <a:srgbClr val="2B211F"/>
                           </a:solidFill>
                           <a:latin typeface="Microsoft YaHei" pitchFamily="34" charset="0"/>
                           <a:ea typeface="Microsoft YaHei" pitchFamily="34" charset="-122"/>
                           <a:cs typeface="Microsoft YaHei" pitchFamily="34" charset="-120"/>
                         </a:rPr>
-                        <a:t>上年同期</a:t>
+                        <a:t>完成率</a:t>
+                      </a:r>
+                      <a:endParaRPr lang="en-US" sz="1100" dirty="0">
+                        <a:latin typeface="Microsoft YaHei" charset="0"/>
+                        <a:ea typeface="Microsoft YaHei" charset="0"/>
+                        <a:cs typeface="Microsoft YaHei" charset="0"/>
+                      </a:endParaRPr>
+                    </a:p>
+                  </a:txBody>
+                  <a:tcPr marL="38100" marR="38100" marT="38100" marB="38100">
+                    <a:lnL w="6350" cap="flat" cmpd="sng" algn="ctr">
+                      <a:solidFill>
+                        <a:srgbClr val="D8DEE8"/>
+                      </a:solidFill>
+                      <a:prstDash val="solid"/>
+                      <a:round/>
+                      <a:headEnd type="none" w="med" len="med"/>
+                      <a:tailEnd type="none" w="med" len="med"/>
+                    </a:lnL>
+                    <a:lnR w="6350" cap="flat" cmpd="sng" algn="ctr">
+                      <a:solidFill>
+                        <a:srgbClr val="D8DEE8"/>
+                      </a:solidFill>
+                      <a:prstDash val="solid"/>
+                      <a:round/>
+                      <a:headEnd type="none" w="med" len="med"/>
+                      <a:tailEnd type="none" w="med" len="med"/>
+                    </a:lnR>
+                    <a:lnT w="6350" cap="flat" cmpd="sng" algn="ctr">
+                      <a:solidFill>
+                        <a:srgbClr val="D8DEE8"/>
+                      </a:solidFill>
+                      <a:prstDash val="solid"/>
+                      <a:round/>
+                      <a:headEnd type="none" w="med" len="med"/>
+                      <a:tailEnd type="none" w="med" len="med"/>
+                    </a:lnT>
+                    <a:lnB w="6350" cap="flat" cmpd="sng" algn="ctr">
+                      <a:solidFill>
+                        <a:srgbClr val="D8DEE8"/>
+                      </a:solidFill>
+                      <a:prstDash val="solid"/>
+                      <a:round/>
+                      <a:headEnd type="none" w="med" len="med"/>
+                      <a:tailEnd type="none" w="med" len="med"/>
+                    </a:lnB>
+                    <a:solidFill>
+                      <a:srgbClr val="FBF9F6"/>
+                    </a:solidFill>
+                  </a:tcPr>
+                </a:tc>
+                <a:tc>
+                  <a:txBody>
+                    <a:bodyPr/>
+                    <a:lstStyle/>
+                    <a:p>
+                      <a:pPr indent="0" marL="0">
+                        <a:buNone/>
+                      </a:pPr>
+                      <a:r>
+                        <a:rPr lang="en-US" sz="1100" dirty="0">
+                          <a:solidFill>
+                            <a:srgbClr val="2B211F"/>
+                          </a:solidFill>
+                          <a:latin typeface="Microsoft YaHei" pitchFamily="34" charset="0"/>
+                          <a:ea typeface="Microsoft YaHei" pitchFamily="34" charset="-122"/>
+                          <a:cs typeface="Microsoft YaHei" pitchFamily="34" charset="-120"/>
+                        </a:rPr>
+                        <a:t>95.6%</a:t>
+                      </a:r>
+                      <a:endParaRPr lang="en-US" sz="1100" dirty="0">
+                        <a:latin typeface="Microsoft YaHei" charset="0"/>
+                        <a:ea typeface="Microsoft YaHei" charset="0"/>
+                        <a:cs typeface="Microsoft YaHei" charset="0"/>
+                      </a:endParaRPr>
+                    </a:p>
+                  </a:txBody>
+                  <a:tcPr marL="38100" marR="38100" marT="38100" marB="38100">
+                    <a:lnL w="6350" cap="flat" cmpd="sng" algn="ctr">
+                      <a:solidFill>
+                        <a:srgbClr val="D8DEE8"/>
+                      </a:solidFill>
+                      <a:prstDash val="solid"/>
+                      <a:round/>
+                      <a:headEnd type="none" w="med" len="med"/>
+                      <a:tailEnd type="none" w="med" len="med"/>
+                    </a:lnL>
+                    <a:lnR w="6350" cap="flat" cmpd="sng" algn="ctr">
+                      <a:solidFill>
+                        <a:srgbClr val="D8DEE8"/>
+                      </a:solidFill>
+                      <a:prstDash val="solid"/>
+                      <a:round/>
+                      <a:headEnd type="none" w="med" len="med"/>
+                      <a:tailEnd type="none" w="med" len="med"/>
+                    </a:lnR>
+                    <a:lnT w="6350" cap="flat" cmpd="sng" algn="ctr">
+                      <a:solidFill>
+                        <a:srgbClr val="D8DEE8"/>
+                      </a:solidFill>
+                      <a:prstDash val="solid"/>
+                      <a:round/>
+                      <a:headEnd type="none" w="med" len="med"/>
+                      <a:tailEnd type="none" w="med" len="med"/>
+                    </a:lnT>
+                    <a:lnB w="6350" cap="flat" cmpd="sng" algn="ctr">
+                      <a:solidFill>
+                        <a:srgbClr val="D8DEE8"/>
+                      </a:solidFill>
+                      <a:prstDash val="solid"/>
+                      <a:round/>
+                      <a:headEnd type="none" w="med" len="med"/>
+                      <a:tailEnd type="none" w="med" len="med"/>
+                    </a:lnB>
+                    <a:solidFill>
+                      <a:srgbClr val="FBF9F6"/>
+                    </a:solidFill>
+                  </a:tcPr>
+                </a:tc>
+              </a:tr>
+              <a:tr h="563880">
+                <a:tc>
+                  <a:txBody>
+                    <a:bodyPr/>
+                    <a:lstStyle/>
+                    <a:p>
+                      <a:pPr indent="0" marL="0">
+                        <a:buNone/>
+                      </a:pPr>
+                      <a:r>
+                        <a:rPr lang="en-US" sz="1100" b="1" dirty="0">
+                          <a:solidFill>
+                            <a:srgbClr val="2B211F"/>
+                          </a:solidFill>
+                          <a:latin typeface="Microsoft YaHei" pitchFamily="34" charset="0"/>
+                          <a:ea typeface="Microsoft YaHei" pitchFamily="34" charset="-122"/>
+                          <a:cs typeface="Microsoft YaHei" pitchFamily="34" charset="-120"/>
+                        </a:rPr>
+                        <a:t>同比</a:t>
                       </a:r>
                       <a:endParaRPr lang="en-US" sz="1100" dirty="0">
                         <a:latin typeface="Microsoft YaHei" charset="0"/>
@@ -2851,283 +3130,7 @@
                       <a:r>
                         <a:rPr lang="en-US" sz="1100" dirty="0">
                           <a:solidFill>
-                            <a:srgbClr val="1F2A27"/>
-                          </a:solidFill>
-                          <a:latin typeface="Microsoft YaHei" pitchFamily="34" charset="0"/>
-                          <a:ea typeface="Microsoft YaHei" pitchFamily="34" charset="-122"/>
-                          <a:cs typeface="Microsoft YaHei" pitchFamily="34" charset="-120"/>
-                        </a:rPr>
-                        <a:t>104383.6</a:t>
-                      </a:r>
-                      <a:endParaRPr lang="en-US" sz="1100" dirty="0">
-                        <a:latin typeface="Microsoft YaHei" charset="0"/>
-                        <a:ea typeface="Microsoft YaHei" charset="0"/>
-                        <a:cs typeface="Microsoft YaHei" charset="0"/>
-                      </a:endParaRPr>
-                    </a:p>
-                  </a:txBody>
-                  <a:tcPr marL="38100" marR="38100" marT="38100" marB="38100">
-                    <a:lnL w="6350" cap="flat" cmpd="sng" algn="ctr">
-                      <a:solidFill>
-                        <a:srgbClr val="D8DEE8"/>
-                      </a:solidFill>
-                      <a:prstDash val="solid"/>
-                      <a:round/>
-                      <a:headEnd type="none" w="med" len="med"/>
-                      <a:tailEnd type="none" w="med" len="med"/>
-                    </a:lnL>
-                    <a:lnR w="6350" cap="flat" cmpd="sng" algn="ctr">
-                      <a:solidFill>
-                        <a:srgbClr val="D8DEE8"/>
-                      </a:solidFill>
-                      <a:prstDash val="solid"/>
-                      <a:round/>
-                      <a:headEnd type="none" w="med" len="med"/>
-                      <a:tailEnd type="none" w="med" len="med"/>
-                    </a:lnR>
-                    <a:lnT w="6350" cap="flat" cmpd="sng" algn="ctr">
-                      <a:solidFill>
-                        <a:srgbClr val="D8DEE8"/>
-                      </a:solidFill>
-                      <a:prstDash val="solid"/>
-                      <a:round/>
-                      <a:headEnd type="none" w="med" len="med"/>
-                      <a:tailEnd type="none" w="med" len="med"/>
-                    </a:lnT>
-                    <a:lnB w="6350" cap="flat" cmpd="sng" algn="ctr">
-                      <a:solidFill>
-                        <a:srgbClr val="D8DEE8"/>
-                      </a:solidFill>
-                      <a:prstDash val="solid"/>
-                      <a:round/>
-                      <a:headEnd type="none" w="med" len="med"/>
-                      <a:tailEnd type="none" w="med" len="med"/>
-                    </a:lnB>
-                    <a:solidFill>
-                      <a:srgbClr val="FFFFFF"/>
-                    </a:solidFill>
-                  </a:tcPr>
-                </a:tc>
-              </a:tr>
-              <a:tr h="563880">
-                <a:tc>
-                  <a:txBody>
-                    <a:bodyPr/>
-                    <a:lstStyle/>
-                    <a:p>
-                      <a:pPr indent="0" marL="0">
-                        <a:buNone/>
-                      </a:pPr>
-                      <a:r>
-                        <a:rPr lang="en-US" sz="1100" dirty="0">
-                          <a:solidFill>
-                            <a:srgbClr val="1F2A27"/>
-                          </a:solidFill>
-                          <a:latin typeface="Microsoft YaHei" pitchFamily="34" charset="0"/>
-                          <a:ea typeface="Microsoft YaHei" pitchFamily="34" charset="-122"/>
-                          <a:cs typeface="Microsoft YaHei" pitchFamily="34" charset="-120"/>
-                        </a:rPr>
-                        <a:t>完成率</a:t>
-                      </a:r>
-                      <a:endParaRPr lang="en-US" sz="1100" dirty="0">
-                        <a:latin typeface="Microsoft YaHei" charset="0"/>
-                        <a:ea typeface="Microsoft YaHei" charset="0"/>
-                        <a:cs typeface="Microsoft YaHei" charset="0"/>
-                      </a:endParaRPr>
-                    </a:p>
-                  </a:txBody>
-                  <a:tcPr marL="38100" marR="38100" marT="38100" marB="38100">
-                    <a:lnL w="6350" cap="flat" cmpd="sng" algn="ctr">
-                      <a:solidFill>
-                        <a:srgbClr val="D8DEE8"/>
-                      </a:solidFill>
-                      <a:prstDash val="solid"/>
-                      <a:round/>
-                      <a:headEnd type="none" w="med" len="med"/>
-                      <a:tailEnd type="none" w="med" len="med"/>
-                    </a:lnL>
-                    <a:lnR w="6350" cap="flat" cmpd="sng" algn="ctr">
-                      <a:solidFill>
-                        <a:srgbClr val="D8DEE8"/>
-                      </a:solidFill>
-                      <a:prstDash val="solid"/>
-                      <a:round/>
-                      <a:headEnd type="none" w="med" len="med"/>
-                      <a:tailEnd type="none" w="med" len="med"/>
-                    </a:lnR>
-                    <a:lnT w="6350" cap="flat" cmpd="sng" algn="ctr">
-                      <a:solidFill>
-                        <a:srgbClr val="D8DEE8"/>
-                      </a:solidFill>
-                      <a:prstDash val="solid"/>
-                      <a:round/>
-                      <a:headEnd type="none" w="med" len="med"/>
-                      <a:tailEnd type="none" w="med" len="med"/>
-                    </a:lnT>
-                    <a:lnB w="6350" cap="flat" cmpd="sng" algn="ctr">
-                      <a:solidFill>
-                        <a:srgbClr val="D8DEE8"/>
-                      </a:solidFill>
-                      <a:prstDash val="solid"/>
-                      <a:round/>
-                      <a:headEnd type="none" w="med" len="med"/>
-                      <a:tailEnd type="none" w="med" len="med"/>
-                    </a:lnB>
-                    <a:solidFill>
-                      <a:srgbClr val="FFFFFF"/>
-                    </a:solidFill>
-                  </a:tcPr>
-                </a:tc>
-                <a:tc>
-                  <a:txBody>
-                    <a:bodyPr/>
-                    <a:lstStyle/>
-                    <a:p>
-                      <a:pPr indent="0" marL="0">
-                        <a:buNone/>
-                      </a:pPr>
-                      <a:r>
-                        <a:rPr lang="en-US" sz="1100" dirty="0">
-                          <a:solidFill>
-                            <a:srgbClr val="1F2A27"/>
-                          </a:solidFill>
-                          <a:latin typeface="Microsoft YaHei" pitchFamily="34" charset="0"/>
-                          <a:ea typeface="Microsoft YaHei" pitchFamily="34" charset="-122"/>
-                          <a:cs typeface="Microsoft YaHei" pitchFamily="34" charset="-120"/>
-                        </a:rPr>
-                        <a:t>95.6%</a:t>
-                      </a:r>
-                      <a:endParaRPr lang="en-US" sz="1100" dirty="0">
-                        <a:latin typeface="Microsoft YaHei" charset="0"/>
-                        <a:ea typeface="Microsoft YaHei" charset="0"/>
-                        <a:cs typeface="Microsoft YaHei" charset="0"/>
-                      </a:endParaRPr>
-                    </a:p>
-                  </a:txBody>
-                  <a:tcPr marL="38100" marR="38100" marT="38100" marB="38100">
-                    <a:lnL w="6350" cap="flat" cmpd="sng" algn="ctr">
-                      <a:solidFill>
-                        <a:srgbClr val="D8DEE8"/>
-                      </a:solidFill>
-                      <a:prstDash val="solid"/>
-                      <a:round/>
-                      <a:headEnd type="none" w="med" len="med"/>
-                      <a:tailEnd type="none" w="med" len="med"/>
-                    </a:lnL>
-                    <a:lnR w="6350" cap="flat" cmpd="sng" algn="ctr">
-                      <a:solidFill>
-                        <a:srgbClr val="D8DEE8"/>
-                      </a:solidFill>
-                      <a:prstDash val="solid"/>
-                      <a:round/>
-                      <a:headEnd type="none" w="med" len="med"/>
-                      <a:tailEnd type="none" w="med" len="med"/>
-                    </a:lnR>
-                    <a:lnT w="6350" cap="flat" cmpd="sng" algn="ctr">
-                      <a:solidFill>
-                        <a:srgbClr val="D8DEE8"/>
-                      </a:solidFill>
-                      <a:prstDash val="solid"/>
-                      <a:round/>
-                      <a:headEnd type="none" w="med" len="med"/>
-                      <a:tailEnd type="none" w="med" len="med"/>
-                    </a:lnT>
-                    <a:lnB w="6350" cap="flat" cmpd="sng" algn="ctr">
-                      <a:solidFill>
-                        <a:srgbClr val="D8DEE8"/>
-                      </a:solidFill>
-                      <a:prstDash val="solid"/>
-                      <a:round/>
-                      <a:headEnd type="none" w="med" len="med"/>
-                      <a:tailEnd type="none" w="med" len="med"/>
-                    </a:lnB>
-                    <a:solidFill>
-                      <a:srgbClr val="FFFFFF"/>
-                    </a:solidFill>
-                  </a:tcPr>
-                </a:tc>
-              </a:tr>
-              <a:tr h="563880">
-                <a:tc>
-                  <a:txBody>
-                    <a:bodyPr/>
-                    <a:lstStyle/>
-                    <a:p>
-                      <a:pPr indent="0" marL="0">
-                        <a:buNone/>
-                      </a:pPr>
-                      <a:r>
-                        <a:rPr lang="en-US" sz="1100" dirty="0">
-                          <a:solidFill>
-                            <a:srgbClr val="1F2A27"/>
-                          </a:solidFill>
-                          <a:latin typeface="Microsoft YaHei" pitchFamily="34" charset="0"/>
-                          <a:ea typeface="Microsoft YaHei" pitchFamily="34" charset="-122"/>
-                          <a:cs typeface="Microsoft YaHei" pitchFamily="34" charset="-120"/>
-                        </a:rPr>
-                        <a:t>同比</a:t>
-                      </a:r>
-                      <a:endParaRPr lang="en-US" sz="1100" dirty="0">
-                        <a:latin typeface="Microsoft YaHei" charset="0"/>
-                        <a:ea typeface="Microsoft YaHei" charset="0"/>
-                        <a:cs typeface="Microsoft YaHei" charset="0"/>
-                      </a:endParaRPr>
-                    </a:p>
-                  </a:txBody>
-                  <a:tcPr marL="38100" marR="38100" marT="38100" marB="38100">
-                    <a:lnL w="6350" cap="flat" cmpd="sng" algn="ctr">
-                      <a:solidFill>
-                        <a:srgbClr val="D8DEE8"/>
-                      </a:solidFill>
-                      <a:prstDash val="solid"/>
-                      <a:round/>
-                      <a:headEnd type="none" w="med" len="med"/>
-                      <a:tailEnd type="none" w="med" len="med"/>
-                    </a:lnL>
-                    <a:lnR w="6350" cap="flat" cmpd="sng" algn="ctr">
-                      <a:solidFill>
-                        <a:srgbClr val="D8DEE8"/>
-                      </a:solidFill>
-                      <a:prstDash val="solid"/>
-                      <a:round/>
-                      <a:headEnd type="none" w="med" len="med"/>
-                      <a:tailEnd type="none" w="med" len="med"/>
-                    </a:lnR>
-                    <a:lnT w="6350" cap="flat" cmpd="sng" algn="ctr">
-                      <a:solidFill>
-                        <a:srgbClr val="D8DEE8"/>
-                      </a:solidFill>
-                      <a:prstDash val="solid"/>
-                      <a:round/>
-                      <a:headEnd type="none" w="med" len="med"/>
-                      <a:tailEnd type="none" w="med" len="med"/>
-                    </a:lnT>
-                    <a:lnB w="6350" cap="flat" cmpd="sng" algn="ctr">
-                      <a:solidFill>
-                        <a:srgbClr val="D8DEE8"/>
-                      </a:solidFill>
-                      <a:prstDash val="solid"/>
-                      <a:round/>
-                      <a:headEnd type="none" w="med" len="med"/>
-                      <a:tailEnd type="none" w="med" len="med"/>
-                    </a:lnB>
-                    <a:solidFill>
-                      <a:srgbClr val="FFFFFF"/>
-                    </a:solidFill>
-                  </a:tcPr>
-                </a:tc>
-                <a:tc>
-                  <a:txBody>
-                    <a:bodyPr/>
-                    <a:lstStyle/>
-                    <a:p>
-                      <a:pPr indent="0" marL="0">
-                        <a:buNone/>
-                      </a:pPr>
-                      <a:r>
-                        <a:rPr lang="en-US" sz="1100" dirty="0">
-                          <a:solidFill>
-                            <a:srgbClr val="1F2A27"/>
+                            <a:srgbClr val="2B211F"/>
                           </a:solidFill>
                           <a:latin typeface="Microsoft YaHei" pitchFamily="34" charset="0"/>
                           <a:ea typeface="Microsoft YaHei" pitchFamily="34" charset="-122"/>
@@ -3207,7 +3210,9 @@
           <a:ln/>
         </p:spPr>
         <p:txBody>
-          <a:bodyPr wrap="square" lIns="50800" tIns="50800" rIns="50800" bIns="50800" rtlCol="0" anchor="t"/>
+          <a:bodyPr wrap="square" lIns="50800" tIns="50800" rIns="50800" bIns="50800" rtlCol="0" anchor="t">
+            <a:normAutofit/>
+          </a:bodyPr>
           <a:lstStyle/>
           <a:p>
             <a:pPr indent="0" marL="0">
@@ -3216,30 +3221,13 @@
             <a:r>
               <a:rPr lang="en-US" sz="1800" dirty="0">
                 <a:solidFill>
-                  <a:srgbClr val="1F2A27"/>
+                  <a:srgbClr val="2B211F"/>
                 </a:solidFill>
                 <a:latin typeface="Microsoft YaHei" pitchFamily="34" charset="0"/>
                 <a:ea typeface="Microsoft YaHei" pitchFamily="34" charset="-122"/>
                 <a:cs typeface="Microsoft YaHei" pitchFamily="34" charset="-120"/>
               </a:rPr>
               <a:t>总体完成率 95.6%，同比 14.7%。</a:t>
-            </a:r>
-            <a:endParaRPr lang="en-US" sz="1800" dirty="0"/>
-          </a:p>
-          <a:p>
-            <a:pPr indent="0" marL="0">
-              <a:buNone/>
-            </a:pPr>
-            <a:r>
-              <a:rPr lang="en-US" sz="1800" dirty="0">
-                <a:solidFill>
-                  <a:srgbClr val="1F2A27"/>
-                </a:solidFill>
-                <a:latin typeface="Microsoft YaHei" pitchFamily="34" charset="0"/>
-                <a:ea typeface="Microsoft YaHei" pitchFamily="34" charset="-122"/>
-                <a:cs typeface="Microsoft YaHei" pitchFamily="34" charset="-120"/>
-              </a:rPr>
-              <a:t>[Evidence: ev-pilot-performance]</a:t>
             </a:r>
             <a:endParaRPr lang="en-US" sz="1800" dirty="0"/>
           </a:p>
@@ -3263,7 +3251,9 @@
           <a:ln/>
         </p:spPr>
         <p:txBody>
-          <a:bodyPr wrap="square" lIns="0" tIns="0" rIns="0" bIns="0" rtlCol="0" anchor="ctr"/>
+          <a:bodyPr wrap="square" lIns="0" tIns="0" rIns="0" bIns="0" rtlCol="0" anchor="ctr">
+            <a:normAutofit/>
+          </a:bodyPr>
           <a:lstStyle/>
           <a:p>
             <a:pPr indent="0" marL="0">
@@ -3272,30 +3262,13 @@
             <a:r>
               <a:rPr lang="en-US" sz="800" dirty="0">
                 <a:solidFill>
-                  <a:srgbClr val="6D7D77"/>
+                  <a:srgbClr val="7D6C68"/>
                 </a:solidFill>
                 <a:latin typeface="Microsoft YaHei" pitchFamily="34" charset="0"/>
                 <a:ea typeface="Microsoft YaHei" pitchFamily="34" charset="-122"/>
                 <a:cs typeface="Microsoft YaHei" pitchFamily="34" charset="-120"/>
               </a:rPr>
               <a:t>数据来源</a:t>
-            </a:r>
-            <a:endParaRPr lang="en-US" sz="800" dirty="0"/>
-          </a:p>
-          <a:p>
-            <a:pPr indent="0" marL="0">
-              <a:buNone/>
-            </a:pPr>
-            <a:r>
-              <a:rPr lang="en-US" sz="800" dirty="0">
-                <a:solidFill>
-                  <a:srgbClr val="6D7D77"/>
-                </a:solidFill>
-                <a:latin typeface="Microsoft YaHei" pitchFamily="34" charset="0"/>
-                <a:ea typeface="Microsoft YaHei" pitchFamily="34" charset="-122"/>
-                <a:cs typeface="Microsoft YaHei" pitchFamily="34" charset="-120"/>
-              </a:rPr>
-              <a:t>[Evidence: ev-pilot-task-total, ev-pilot-current-total, ev-pilot-prior-total, ev-pilot-performance]</a:t>
             </a:r>
             <a:endParaRPr lang="en-US" sz="800" dirty="0"/>
           </a:p>
@@ -3361,7 +3334,7 @@
             <a:lvl1pPr>
               <a:defRPr sz="900">
                 <a:solidFill>
-                  <a:srgbClr val="6D7D77"/>
+                  <a:srgbClr val="7D6C68"/>
                 </a:solidFill>
                 <a:latin typeface="Microsoft YaHei"/>
                 <a:ea typeface="Microsoft YaHei"/>
@@ -3433,7 +3406,7 @@
             <a:r>
               <a:rPr lang="en-US" sz="2400" b="1" dirty="0">
                 <a:solidFill>
-                  <a:srgbClr val="24443A"/>
+                  <a:srgbClr val="8B1E1E"/>
                 </a:solidFill>
                 <a:latin typeface="Microsoft YaHei" pitchFamily="34" charset="0"/>
                 <a:ea typeface="Microsoft YaHei" pitchFamily="34" charset="-122"/>
@@ -3537,7 +3510,7 @@
                       <a:tailEnd type="none" w="med" len="med"/>
                     </a:lnB>
                     <a:solidFill>
-                      <a:srgbClr val="24443A"/>
+                      <a:srgbClr val="8B1E1E"/>
                     </a:solidFill>
                   </a:tcPr>
                 </a:tc>
@@ -3605,7 +3578,7 @@
                       <a:tailEnd type="none" w="med" len="med"/>
                     </a:lnB>
                     <a:solidFill>
-                      <a:srgbClr val="24443A"/>
+                      <a:srgbClr val="8B1E1E"/>
                     </a:solidFill>
                   </a:tcPr>
                 </a:tc>
@@ -3673,7 +3646,7 @@
                       <a:tailEnd type="none" w="med" len="med"/>
                     </a:lnB>
                     <a:solidFill>
-                      <a:srgbClr val="24443A"/>
+                      <a:srgbClr val="8B1E1E"/>
                     </a:solidFill>
                   </a:tcPr>
                 </a:tc>
@@ -3688,9 +3661,9 @@
                         <a:buNone/>
                       </a:pPr>
                       <a:r>
-                        <a:rPr lang="en-US" sz="1100" dirty="0">
+                        <a:rPr lang="en-US" sz="1100" b="1" dirty="0">
                           <a:solidFill>
-                            <a:srgbClr val="1F2A27"/>
+                            <a:srgbClr val="2B211F"/>
                           </a:solidFill>
                           <a:latin typeface="Microsoft YaHei" pitchFamily="34" charset="0"/>
                           <a:ea typeface="Microsoft YaHei" pitchFamily="34" charset="-122"/>
@@ -3758,7 +3731,7 @@
                       <a:r>
                         <a:rPr lang="en-US" sz="1100" dirty="0">
                           <a:solidFill>
-                            <a:srgbClr val="1F2A27"/>
+                            <a:srgbClr val="2B211F"/>
                           </a:solidFill>
                           <a:latin typeface="Microsoft YaHei" pitchFamily="34" charset="0"/>
                           <a:ea typeface="Microsoft YaHei" pitchFamily="34" charset="-122"/>
@@ -3826,7 +3799,7 @@
                       <a:r>
                         <a:rPr lang="en-US" sz="1100" dirty="0">
                           <a:solidFill>
-                            <a:srgbClr val="1F2A27"/>
+                            <a:srgbClr val="2B211F"/>
                           </a:solidFill>
                           <a:latin typeface="Microsoft YaHei" pitchFamily="34" charset="0"/>
                           <a:ea typeface="Microsoft YaHei" pitchFamily="34" charset="-122"/>
@@ -3894,15 +3867,221 @@
                         <a:buNone/>
                       </a:pPr>
                       <a:r>
-                        <a:rPr lang="en-US" sz="1100" dirty="0">
+                        <a:rPr lang="en-US" sz="1100" b="1" dirty="0">
                           <a:solidFill>
-                            <a:srgbClr val="1F2A27"/>
+                            <a:srgbClr val="2B211F"/>
                           </a:solidFill>
                           <a:latin typeface="Microsoft YaHei" pitchFamily="34" charset="0"/>
                           <a:ea typeface="Microsoft YaHei" pitchFamily="34" charset="-122"/>
                           <a:cs typeface="Microsoft YaHei" pitchFamily="34" charset="-120"/>
                         </a:rPr>
                         <a:t>销售员004</a:t>
+                      </a:r>
+                      <a:endParaRPr lang="en-US" sz="1100" dirty="0">
+                        <a:latin typeface="Microsoft YaHei" charset="0"/>
+                        <a:ea typeface="Microsoft YaHei" charset="0"/>
+                        <a:cs typeface="Microsoft YaHei" charset="0"/>
+                      </a:endParaRPr>
+                    </a:p>
+                  </a:txBody>
+                  <a:tcPr marL="38100" marR="38100" marT="38100" marB="38100">
+                    <a:lnL w="6350" cap="flat" cmpd="sng" algn="ctr">
+                      <a:solidFill>
+                        <a:srgbClr val="D8DEE8"/>
+                      </a:solidFill>
+                      <a:prstDash val="solid"/>
+                      <a:round/>
+                      <a:headEnd type="none" w="med" len="med"/>
+                      <a:tailEnd type="none" w="med" len="med"/>
+                    </a:lnL>
+                    <a:lnR w="6350" cap="flat" cmpd="sng" algn="ctr">
+                      <a:solidFill>
+                        <a:srgbClr val="D8DEE8"/>
+                      </a:solidFill>
+                      <a:prstDash val="solid"/>
+                      <a:round/>
+                      <a:headEnd type="none" w="med" len="med"/>
+                      <a:tailEnd type="none" w="med" len="med"/>
+                    </a:lnR>
+                    <a:lnT w="6350" cap="flat" cmpd="sng" algn="ctr">
+                      <a:solidFill>
+                        <a:srgbClr val="D8DEE8"/>
+                      </a:solidFill>
+                      <a:prstDash val="solid"/>
+                      <a:round/>
+                      <a:headEnd type="none" w="med" len="med"/>
+                      <a:tailEnd type="none" w="med" len="med"/>
+                    </a:lnT>
+                    <a:lnB w="6350" cap="flat" cmpd="sng" algn="ctr">
+                      <a:solidFill>
+                        <a:srgbClr val="D8DEE8"/>
+                      </a:solidFill>
+                      <a:prstDash val="solid"/>
+                      <a:round/>
+                      <a:headEnd type="none" w="med" len="med"/>
+                      <a:tailEnd type="none" w="med" len="med"/>
+                    </a:lnB>
+                    <a:solidFill>
+                      <a:srgbClr val="FBF9F6"/>
+                    </a:solidFill>
+                  </a:tcPr>
+                </a:tc>
+                <a:tc>
+                  <a:txBody>
+                    <a:bodyPr/>
+                    <a:lstStyle/>
+                    <a:p>
+                      <a:pPr indent="0" marL="0">
+                        <a:buNone/>
+                      </a:pPr>
+                      <a:r>
+                        <a:rPr lang="en-US" sz="1100" dirty="0">
+                          <a:solidFill>
+                            <a:srgbClr val="2B211F"/>
+                          </a:solidFill>
+                          <a:latin typeface="Microsoft YaHei" pitchFamily="34" charset="0"/>
+                          <a:ea typeface="Microsoft YaHei" pitchFamily="34" charset="-122"/>
+                          <a:cs typeface="Microsoft YaHei" pitchFamily="34" charset="-120"/>
+                        </a:rPr>
+                        <a:t>6556</a:t>
+                      </a:r>
+                      <a:endParaRPr lang="en-US" sz="1100" dirty="0">
+                        <a:latin typeface="Microsoft YaHei" charset="0"/>
+                        <a:ea typeface="Microsoft YaHei" charset="0"/>
+                        <a:cs typeface="Microsoft YaHei" charset="0"/>
+                      </a:endParaRPr>
+                    </a:p>
+                  </a:txBody>
+                  <a:tcPr marL="38100" marR="38100" marT="38100" marB="38100">
+                    <a:lnL w="6350" cap="flat" cmpd="sng" algn="ctr">
+                      <a:solidFill>
+                        <a:srgbClr val="D8DEE8"/>
+                      </a:solidFill>
+                      <a:prstDash val="solid"/>
+                      <a:round/>
+                      <a:headEnd type="none" w="med" len="med"/>
+                      <a:tailEnd type="none" w="med" len="med"/>
+                    </a:lnL>
+                    <a:lnR w="6350" cap="flat" cmpd="sng" algn="ctr">
+                      <a:solidFill>
+                        <a:srgbClr val="D8DEE8"/>
+                      </a:solidFill>
+                      <a:prstDash val="solid"/>
+                      <a:round/>
+                      <a:headEnd type="none" w="med" len="med"/>
+                      <a:tailEnd type="none" w="med" len="med"/>
+                    </a:lnR>
+                    <a:lnT w="6350" cap="flat" cmpd="sng" algn="ctr">
+                      <a:solidFill>
+                        <a:srgbClr val="D8DEE8"/>
+                      </a:solidFill>
+                      <a:prstDash val="solid"/>
+                      <a:round/>
+                      <a:headEnd type="none" w="med" len="med"/>
+                      <a:tailEnd type="none" w="med" len="med"/>
+                    </a:lnT>
+                    <a:lnB w="6350" cap="flat" cmpd="sng" algn="ctr">
+                      <a:solidFill>
+                        <a:srgbClr val="D8DEE8"/>
+                      </a:solidFill>
+                      <a:prstDash val="solid"/>
+                      <a:round/>
+                      <a:headEnd type="none" w="med" len="med"/>
+                      <a:tailEnd type="none" w="med" len="med"/>
+                    </a:lnB>
+                    <a:solidFill>
+                      <a:srgbClr val="FBF9F6"/>
+                    </a:solidFill>
+                  </a:tcPr>
+                </a:tc>
+                <a:tc>
+                  <a:txBody>
+                    <a:bodyPr/>
+                    <a:lstStyle/>
+                    <a:p>
+                      <a:pPr indent="0" marL="0">
+                        <a:buNone/>
+                      </a:pPr>
+                      <a:r>
+                        <a:rPr lang="en-US" sz="1100" dirty="0">
+                          <a:solidFill>
+                            <a:srgbClr val="2B211F"/>
+                          </a:solidFill>
+                          <a:latin typeface="Microsoft YaHei" pitchFamily="34" charset="0"/>
+                          <a:ea typeface="Microsoft YaHei" pitchFamily="34" charset="-122"/>
+                          <a:cs typeface="Microsoft YaHei" pitchFamily="34" charset="-120"/>
+                        </a:rPr>
+                        <a:t>6823.5</a:t>
+                      </a:r>
+                      <a:endParaRPr lang="en-US" sz="1100" dirty="0">
+                        <a:latin typeface="Microsoft YaHei" charset="0"/>
+                        <a:ea typeface="Microsoft YaHei" charset="0"/>
+                        <a:cs typeface="Microsoft YaHei" charset="0"/>
+                      </a:endParaRPr>
+                    </a:p>
+                  </a:txBody>
+                  <a:tcPr marL="38100" marR="38100" marT="38100" marB="38100">
+                    <a:lnL w="6350" cap="flat" cmpd="sng" algn="ctr">
+                      <a:solidFill>
+                        <a:srgbClr val="D8DEE8"/>
+                      </a:solidFill>
+                      <a:prstDash val="solid"/>
+                      <a:round/>
+                      <a:headEnd type="none" w="med" len="med"/>
+                      <a:tailEnd type="none" w="med" len="med"/>
+                    </a:lnL>
+                    <a:lnR w="6350" cap="flat" cmpd="sng" algn="ctr">
+                      <a:solidFill>
+                        <a:srgbClr val="D8DEE8"/>
+                      </a:solidFill>
+                      <a:prstDash val="solid"/>
+                      <a:round/>
+                      <a:headEnd type="none" w="med" len="med"/>
+                      <a:tailEnd type="none" w="med" len="med"/>
+                    </a:lnR>
+                    <a:lnT w="6350" cap="flat" cmpd="sng" algn="ctr">
+                      <a:solidFill>
+                        <a:srgbClr val="D8DEE8"/>
+                      </a:solidFill>
+                      <a:prstDash val="solid"/>
+                      <a:round/>
+                      <a:headEnd type="none" w="med" len="med"/>
+                      <a:tailEnd type="none" w="med" len="med"/>
+                    </a:lnT>
+                    <a:lnB w="6350" cap="flat" cmpd="sng" algn="ctr">
+                      <a:solidFill>
+                        <a:srgbClr val="D8DEE8"/>
+                      </a:solidFill>
+                      <a:prstDash val="solid"/>
+                      <a:round/>
+                      <a:headEnd type="none" w="med" len="med"/>
+                      <a:tailEnd type="none" w="med" len="med"/>
+                    </a:lnB>
+                    <a:solidFill>
+                      <a:srgbClr val="FBF9F6"/>
+                    </a:solidFill>
+                  </a:tcPr>
+                </a:tc>
+              </a:tr>
+              <a:tr h="548640">
+                <a:tc>
+                  <a:txBody>
+                    <a:bodyPr/>
+                    <a:lstStyle/>
+                    <a:p>
+                      <a:pPr indent="0" marL="0">
+                        <a:buNone/>
+                      </a:pPr>
+                      <a:r>
+                        <a:rPr lang="en-US" sz="1100" b="1" dirty="0">
+                          <a:solidFill>
+                            <a:srgbClr val="2B211F"/>
+                          </a:solidFill>
+                          <a:latin typeface="Microsoft YaHei" pitchFamily="34" charset="0"/>
+                          <a:ea typeface="Microsoft YaHei" pitchFamily="34" charset="-122"/>
+                          <a:cs typeface="Microsoft YaHei" pitchFamily="34" charset="-120"/>
+                        </a:rPr>
+                        <a:t>销售员002</a:t>
                       </a:r>
                       <a:endParaRPr lang="en-US" sz="1100" dirty="0">
                         <a:latin typeface="Microsoft YaHei" charset="0"/>
@@ -3964,13 +4143,13 @@
                       <a:r>
                         <a:rPr lang="en-US" sz="1100" dirty="0">
                           <a:solidFill>
-                            <a:srgbClr val="1F2A27"/>
+                            <a:srgbClr val="2B211F"/>
                           </a:solidFill>
                           <a:latin typeface="Microsoft YaHei" pitchFamily="34" charset="0"/>
                           <a:ea typeface="Microsoft YaHei" pitchFamily="34" charset="-122"/>
                           <a:cs typeface="Microsoft YaHei" pitchFamily="34" charset="-120"/>
                         </a:rPr>
-                        <a:t>6556</a:t>
+                        <a:t>6676.5</a:t>
                       </a:r>
                       <a:endParaRPr lang="en-US" sz="1100" dirty="0">
                         <a:latin typeface="Microsoft YaHei" charset="0"/>
@@ -4032,13 +4211,13 @@
                       <a:r>
                         <a:rPr lang="en-US" sz="1100" dirty="0">
                           <a:solidFill>
-                            <a:srgbClr val="1F2A27"/>
+                            <a:srgbClr val="2B211F"/>
                           </a:solidFill>
                           <a:latin typeface="Microsoft YaHei" pitchFamily="34" charset="0"/>
                           <a:ea typeface="Microsoft YaHei" pitchFamily="34" charset="-122"/>
                           <a:cs typeface="Microsoft YaHei" pitchFamily="34" charset="-120"/>
                         </a:rPr>
-                        <a:t>6823.5</a:t>
+                        <a:t>5776</a:t>
                       </a:r>
                       <a:endParaRPr lang="en-US" sz="1100" dirty="0">
                         <a:latin typeface="Microsoft YaHei" charset="0"/>
@@ -4100,15 +4279,221 @@
                         <a:buNone/>
                       </a:pPr>
                       <a:r>
-                        <a:rPr lang="en-US" sz="1100" dirty="0">
+                        <a:rPr lang="en-US" sz="1100" b="1" dirty="0">
                           <a:solidFill>
-                            <a:srgbClr val="1F2A27"/>
+                            <a:srgbClr val="2B211F"/>
                           </a:solidFill>
                           <a:latin typeface="Microsoft YaHei" pitchFamily="34" charset="0"/>
                           <a:ea typeface="Microsoft YaHei" pitchFamily="34" charset="-122"/>
                           <a:cs typeface="Microsoft YaHei" pitchFamily="34" charset="-120"/>
                         </a:rPr>
-                        <a:t>销售员002</a:t>
+                        <a:t>销售员001</a:t>
+                      </a:r>
+                      <a:endParaRPr lang="en-US" sz="1100" dirty="0">
+                        <a:latin typeface="Microsoft YaHei" charset="0"/>
+                        <a:ea typeface="Microsoft YaHei" charset="0"/>
+                        <a:cs typeface="Microsoft YaHei" charset="0"/>
+                      </a:endParaRPr>
+                    </a:p>
+                  </a:txBody>
+                  <a:tcPr marL="38100" marR="38100" marT="38100" marB="38100">
+                    <a:lnL w="6350" cap="flat" cmpd="sng" algn="ctr">
+                      <a:solidFill>
+                        <a:srgbClr val="D8DEE8"/>
+                      </a:solidFill>
+                      <a:prstDash val="solid"/>
+                      <a:round/>
+                      <a:headEnd type="none" w="med" len="med"/>
+                      <a:tailEnd type="none" w="med" len="med"/>
+                    </a:lnL>
+                    <a:lnR w="6350" cap="flat" cmpd="sng" algn="ctr">
+                      <a:solidFill>
+                        <a:srgbClr val="D8DEE8"/>
+                      </a:solidFill>
+                      <a:prstDash val="solid"/>
+                      <a:round/>
+                      <a:headEnd type="none" w="med" len="med"/>
+                      <a:tailEnd type="none" w="med" len="med"/>
+                    </a:lnR>
+                    <a:lnT w="6350" cap="flat" cmpd="sng" algn="ctr">
+                      <a:solidFill>
+                        <a:srgbClr val="D8DEE8"/>
+                      </a:solidFill>
+                      <a:prstDash val="solid"/>
+                      <a:round/>
+                      <a:headEnd type="none" w="med" len="med"/>
+                      <a:tailEnd type="none" w="med" len="med"/>
+                    </a:lnT>
+                    <a:lnB w="6350" cap="flat" cmpd="sng" algn="ctr">
+                      <a:solidFill>
+                        <a:srgbClr val="D8DEE8"/>
+                      </a:solidFill>
+                      <a:prstDash val="solid"/>
+                      <a:round/>
+                      <a:headEnd type="none" w="med" len="med"/>
+                      <a:tailEnd type="none" w="med" len="med"/>
+                    </a:lnB>
+                    <a:solidFill>
+                      <a:srgbClr val="FBF9F6"/>
+                    </a:solidFill>
+                  </a:tcPr>
+                </a:tc>
+                <a:tc>
+                  <a:txBody>
+                    <a:bodyPr/>
+                    <a:lstStyle/>
+                    <a:p>
+                      <a:pPr indent="0" marL="0">
+                        <a:buNone/>
+                      </a:pPr>
+                      <a:r>
+                        <a:rPr lang="en-US" sz="1100" dirty="0">
+                          <a:solidFill>
+                            <a:srgbClr val="2B211F"/>
+                          </a:solidFill>
+                          <a:latin typeface="Microsoft YaHei" pitchFamily="34" charset="0"/>
+                          <a:ea typeface="Microsoft YaHei" pitchFamily="34" charset="-122"/>
+                          <a:cs typeface="Microsoft YaHei" pitchFamily="34" charset="-120"/>
+                        </a:rPr>
+                        <a:t>8850.5</a:t>
+                      </a:r>
+                      <a:endParaRPr lang="en-US" sz="1100" dirty="0">
+                        <a:latin typeface="Microsoft YaHei" charset="0"/>
+                        <a:ea typeface="Microsoft YaHei" charset="0"/>
+                        <a:cs typeface="Microsoft YaHei" charset="0"/>
+                      </a:endParaRPr>
+                    </a:p>
+                  </a:txBody>
+                  <a:tcPr marL="38100" marR="38100" marT="38100" marB="38100">
+                    <a:lnL w="6350" cap="flat" cmpd="sng" algn="ctr">
+                      <a:solidFill>
+                        <a:srgbClr val="D8DEE8"/>
+                      </a:solidFill>
+                      <a:prstDash val="solid"/>
+                      <a:round/>
+                      <a:headEnd type="none" w="med" len="med"/>
+                      <a:tailEnd type="none" w="med" len="med"/>
+                    </a:lnL>
+                    <a:lnR w="6350" cap="flat" cmpd="sng" algn="ctr">
+                      <a:solidFill>
+                        <a:srgbClr val="D8DEE8"/>
+                      </a:solidFill>
+                      <a:prstDash val="solid"/>
+                      <a:round/>
+                      <a:headEnd type="none" w="med" len="med"/>
+                      <a:tailEnd type="none" w="med" len="med"/>
+                    </a:lnR>
+                    <a:lnT w="6350" cap="flat" cmpd="sng" algn="ctr">
+                      <a:solidFill>
+                        <a:srgbClr val="D8DEE8"/>
+                      </a:solidFill>
+                      <a:prstDash val="solid"/>
+                      <a:round/>
+                      <a:headEnd type="none" w="med" len="med"/>
+                      <a:tailEnd type="none" w="med" len="med"/>
+                    </a:lnT>
+                    <a:lnB w="6350" cap="flat" cmpd="sng" algn="ctr">
+                      <a:solidFill>
+                        <a:srgbClr val="D8DEE8"/>
+                      </a:solidFill>
+                      <a:prstDash val="solid"/>
+                      <a:round/>
+                      <a:headEnd type="none" w="med" len="med"/>
+                      <a:tailEnd type="none" w="med" len="med"/>
+                    </a:lnB>
+                    <a:solidFill>
+                      <a:srgbClr val="FBF9F6"/>
+                    </a:solidFill>
+                  </a:tcPr>
+                </a:tc>
+                <a:tc>
+                  <a:txBody>
+                    <a:bodyPr/>
+                    <a:lstStyle/>
+                    <a:p>
+                      <a:pPr indent="0" marL="0">
+                        <a:buNone/>
+                      </a:pPr>
+                      <a:r>
+                        <a:rPr lang="en-US" sz="1100" dirty="0">
+                          <a:solidFill>
+                            <a:srgbClr val="2B211F"/>
+                          </a:solidFill>
+                          <a:latin typeface="Microsoft YaHei" pitchFamily="34" charset="0"/>
+                          <a:ea typeface="Microsoft YaHei" pitchFamily="34" charset="-122"/>
+                          <a:cs typeface="Microsoft YaHei" pitchFamily="34" charset="-120"/>
+                        </a:rPr>
+                        <a:t>7142</a:t>
+                      </a:r>
+                      <a:endParaRPr lang="en-US" sz="1100" dirty="0">
+                        <a:latin typeface="Microsoft YaHei" charset="0"/>
+                        <a:ea typeface="Microsoft YaHei" charset="0"/>
+                        <a:cs typeface="Microsoft YaHei" charset="0"/>
+                      </a:endParaRPr>
+                    </a:p>
+                  </a:txBody>
+                  <a:tcPr marL="38100" marR="38100" marT="38100" marB="38100">
+                    <a:lnL w="6350" cap="flat" cmpd="sng" algn="ctr">
+                      <a:solidFill>
+                        <a:srgbClr val="D8DEE8"/>
+                      </a:solidFill>
+                      <a:prstDash val="solid"/>
+                      <a:round/>
+                      <a:headEnd type="none" w="med" len="med"/>
+                      <a:tailEnd type="none" w="med" len="med"/>
+                    </a:lnL>
+                    <a:lnR w="6350" cap="flat" cmpd="sng" algn="ctr">
+                      <a:solidFill>
+                        <a:srgbClr val="D8DEE8"/>
+                      </a:solidFill>
+                      <a:prstDash val="solid"/>
+                      <a:round/>
+                      <a:headEnd type="none" w="med" len="med"/>
+                      <a:tailEnd type="none" w="med" len="med"/>
+                    </a:lnR>
+                    <a:lnT w="6350" cap="flat" cmpd="sng" algn="ctr">
+                      <a:solidFill>
+                        <a:srgbClr val="D8DEE8"/>
+                      </a:solidFill>
+                      <a:prstDash val="solid"/>
+                      <a:round/>
+                      <a:headEnd type="none" w="med" len="med"/>
+                      <a:tailEnd type="none" w="med" len="med"/>
+                    </a:lnT>
+                    <a:lnB w="6350" cap="flat" cmpd="sng" algn="ctr">
+                      <a:solidFill>
+                        <a:srgbClr val="D8DEE8"/>
+                      </a:solidFill>
+                      <a:prstDash val="solid"/>
+                      <a:round/>
+                      <a:headEnd type="none" w="med" len="med"/>
+                      <a:tailEnd type="none" w="med" len="med"/>
+                    </a:lnB>
+                    <a:solidFill>
+                      <a:srgbClr val="FBF9F6"/>
+                    </a:solidFill>
+                  </a:tcPr>
+                </a:tc>
+              </a:tr>
+              <a:tr h="548640">
+                <a:tc>
+                  <a:txBody>
+                    <a:bodyPr/>
+                    <a:lstStyle/>
+                    <a:p>
+                      <a:pPr indent="0" marL="0">
+                        <a:buNone/>
+                      </a:pPr>
+                      <a:r>
+                        <a:rPr lang="en-US" sz="1100" b="1" dirty="0">
+                          <a:solidFill>
+                            <a:srgbClr val="2B211F"/>
+                          </a:solidFill>
+                          <a:latin typeface="Microsoft YaHei" pitchFamily="34" charset="0"/>
+                          <a:ea typeface="Microsoft YaHei" pitchFamily="34" charset="-122"/>
+                          <a:cs typeface="Microsoft YaHei" pitchFamily="34" charset="-120"/>
+                        </a:rPr>
+                        <a:t>销售员006</a:t>
                       </a:r>
                       <a:endParaRPr lang="en-US" sz="1100" dirty="0">
                         <a:latin typeface="Microsoft YaHei" charset="0"/>
@@ -4170,13 +4555,13 @@
                       <a:r>
                         <a:rPr lang="en-US" sz="1100" dirty="0">
                           <a:solidFill>
-                            <a:srgbClr val="1F2A27"/>
+                            <a:srgbClr val="2B211F"/>
                           </a:solidFill>
                           <a:latin typeface="Microsoft YaHei" pitchFamily="34" charset="0"/>
                           <a:ea typeface="Microsoft YaHei" pitchFamily="34" charset="-122"/>
                           <a:cs typeface="Microsoft YaHei" pitchFamily="34" charset="-120"/>
                         </a:rPr>
-                        <a:t>6676.5</a:t>
+                        <a:t>13438.2</a:t>
                       </a:r>
                       <a:endParaRPr lang="en-US" sz="1100" dirty="0">
                         <a:latin typeface="Microsoft YaHei" charset="0"/>
@@ -4238,13 +4623,13 @@
                       <a:r>
                         <a:rPr lang="en-US" sz="1100" dirty="0">
                           <a:solidFill>
-                            <a:srgbClr val="1F2A27"/>
+                            <a:srgbClr val="2B211F"/>
                           </a:solidFill>
                           <a:latin typeface="Microsoft YaHei" pitchFamily="34" charset="0"/>
                           <a:ea typeface="Microsoft YaHei" pitchFamily="34" charset="-122"/>
                           <a:cs typeface="Microsoft YaHei" pitchFamily="34" charset="-120"/>
                         </a:rPr>
-                        <a:t>5776</a:t>
+                        <a:t>11588.8</a:t>
                       </a:r>
                       <a:endParaRPr lang="en-US" sz="1100" dirty="0">
                         <a:latin typeface="Microsoft YaHei" charset="0"/>
@@ -4306,15 +4691,221 @@
                         <a:buNone/>
                       </a:pPr>
                       <a:r>
-                        <a:rPr lang="en-US" sz="1100" dirty="0">
+                        <a:rPr lang="en-US" sz="1100" b="1" dirty="0">
                           <a:solidFill>
-                            <a:srgbClr val="1F2A27"/>
+                            <a:srgbClr val="2B211F"/>
                           </a:solidFill>
                           <a:latin typeface="Microsoft YaHei" pitchFamily="34" charset="0"/>
                           <a:ea typeface="Microsoft YaHei" pitchFamily="34" charset="-122"/>
                           <a:cs typeface="Microsoft YaHei" pitchFamily="34" charset="-120"/>
                         </a:rPr>
-                        <a:t>销售员001</a:t>
+                        <a:t>销售员005</a:t>
+                      </a:r>
+                      <a:endParaRPr lang="en-US" sz="1100" dirty="0">
+                        <a:latin typeface="Microsoft YaHei" charset="0"/>
+                        <a:ea typeface="Microsoft YaHei" charset="0"/>
+                        <a:cs typeface="Microsoft YaHei" charset="0"/>
+                      </a:endParaRPr>
+                    </a:p>
+                  </a:txBody>
+                  <a:tcPr marL="38100" marR="38100" marT="38100" marB="38100">
+                    <a:lnL w="6350" cap="flat" cmpd="sng" algn="ctr">
+                      <a:solidFill>
+                        <a:srgbClr val="D8DEE8"/>
+                      </a:solidFill>
+                      <a:prstDash val="solid"/>
+                      <a:round/>
+                      <a:headEnd type="none" w="med" len="med"/>
+                      <a:tailEnd type="none" w="med" len="med"/>
+                    </a:lnL>
+                    <a:lnR w="6350" cap="flat" cmpd="sng" algn="ctr">
+                      <a:solidFill>
+                        <a:srgbClr val="D8DEE8"/>
+                      </a:solidFill>
+                      <a:prstDash val="solid"/>
+                      <a:round/>
+                      <a:headEnd type="none" w="med" len="med"/>
+                      <a:tailEnd type="none" w="med" len="med"/>
+                    </a:lnR>
+                    <a:lnT w="6350" cap="flat" cmpd="sng" algn="ctr">
+                      <a:solidFill>
+                        <a:srgbClr val="D8DEE8"/>
+                      </a:solidFill>
+                      <a:prstDash val="solid"/>
+                      <a:round/>
+                      <a:headEnd type="none" w="med" len="med"/>
+                      <a:tailEnd type="none" w="med" len="med"/>
+                    </a:lnT>
+                    <a:lnB w="6350" cap="flat" cmpd="sng" algn="ctr">
+                      <a:solidFill>
+                        <a:srgbClr val="D8DEE8"/>
+                      </a:solidFill>
+                      <a:prstDash val="solid"/>
+                      <a:round/>
+                      <a:headEnd type="none" w="med" len="med"/>
+                      <a:tailEnd type="none" w="med" len="med"/>
+                    </a:lnB>
+                    <a:solidFill>
+                      <a:srgbClr val="FBF9F6"/>
+                    </a:solidFill>
+                  </a:tcPr>
+                </a:tc>
+                <a:tc>
+                  <a:txBody>
+                    <a:bodyPr/>
+                    <a:lstStyle/>
+                    <a:p>
+                      <a:pPr indent="0" marL="0">
+                        <a:buNone/>
+                      </a:pPr>
+                      <a:r>
+                        <a:rPr lang="en-US" sz="1100" dirty="0">
+                          <a:solidFill>
+                            <a:srgbClr val="2B211F"/>
+                          </a:solidFill>
+                          <a:latin typeface="Microsoft YaHei" pitchFamily="34" charset="0"/>
+                          <a:ea typeface="Microsoft YaHei" pitchFamily="34" charset="-122"/>
+                          <a:cs typeface="Microsoft YaHei" pitchFamily="34" charset="-120"/>
+                        </a:rPr>
+                        <a:t>16700.8</a:t>
+                      </a:r>
+                      <a:endParaRPr lang="en-US" sz="1100" dirty="0">
+                        <a:latin typeface="Microsoft YaHei" charset="0"/>
+                        <a:ea typeface="Microsoft YaHei" charset="0"/>
+                        <a:cs typeface="Microsoft YaHei" charset="0"/>
+                      </a:endParaRPr>
+                    </a:p>
+                  </a:txBody>
+                  <a:tcPr marL="38100" marR="38100" marT="38100" marB="38100">
+                    <a:lnL w="6350" cap="flat" cmpd="sng" algn="ctr">
+                      <a:solidFill>
+                        <a:srgbClr val="D8DEE8"/>
+                      </a:solidFill>
+                      <a:prstDash val="solid"/>
+                      <a:round/>
+                      <a:headEnd type="none" w="med" len="med"/>
+                      <a:tailEnd type="none" w="med" len="med"/>
+                    </a:lnL>
+                    <a:lnR w="6350" cap="flat" cmpd="sng" algn="ctr">
+                      <a:solidFill>
+                        <a:srgbClr val="D8DEE8"/>
+                      </a:solidFill>
+                      <a:prstDash val="solid"/>
+                      <a:round/>
+                      <a:headEnd type="none" w="med" len="med"/>
+                      <a:tailEnd type="none" w="med" len="med"/>
+                    </a:lnR>
+                    <a:lnT w="6350" cap="flat" cmpd="sng" algn="ctr">
+                      <a:solidFill>
+                        <a:srgbClr val="D8DEE8"/>
+                      </a:solidFill>
+                      <a:prstDash val="solid"/>
+                      <a:round/>
+                      <a:headEnd type="none" w="med" len="med"/>
+                      <a:tailEnd type="none" w="med" len="med"/>
+                    </a:lnT>
+                    <a:lnB w="6350" cap="flat" cmpd="sng" algn="ctr">
+                      <a:solidFill>
+                        <a:srgbClr val="D8DEE8"/>
+                      </a:solidFill>
+                      <a:prstDash val="solid"/>
+                      <a:round/>
+                      <a:headEnd type="none" w="med" len="med"/>
+                      <a:tailEnd type="none" w="med" len="med"/>
+                    </a:lnB>
+                    <a:solidFill>
+                      <a:srgbClr val="FBF9F6"/>
+                    </a:solidFill>
+                  </a:tcPr>
+                </a:tc>
+                <a:tc>
+                  <a:txBody>
+                    <a:bodyPr/>
+                    <a:lstStyle/>
+                    <a:p>
+                      <a:pPr indent="0" marL="0">
+                        <a:buNone/>
+                      </a:pPr>
+                      <a:r>
+                        <a:rPr lang="en-US" sz="1100" dirty="0">
+                          <a:solidFill>
+                            <a:srgbClr val="2B211F"/>
+                          </a:solidFill>
+                          <a:latin typeface="Microsoft YaHei" pitchFamily="34" charset="0"/>
+                          <a:ea typeface="Microsoft YaHei" pitchFamily="34" charset="-122"/>
+                          <a:cs typeface="Microsoft YaHei" pitchFamily="34" charset="-120"/>
+                        </a:rPr>
+                        <a:t>12610.5</a:t>
+                      </a:r>
+                      <a:endParaRPr lang="en-US" sz="1100" dirty="0">
+                        <a:latin typeface="Microsoft YaHei" charset="0"/>
+                        <a:ea typeface="Microsoft YaHei" charset="0"/>
+                        <a:cs typeface="Microsoft YaHei" charset="0"/>
+                      </a:endParaRPr>
+                    </a:p>
+                  </a:txBody>
+                  <a:tcPr marL="38100" marR="38100" marT="38100" marB="38100">
+                    <a:lnL w="6350" cap="flat" cmpd="sng" algn="ctr">
+                      <a:solidFill>
+                        <a:srgbClr val="D8DEE8"/>
+                      </a:solidFill>
+                      <a:prstDash val="solid"/>
+                      <a:round/>
+                      <a:headEnd type="none" w="med" len="med"/>
+                      <a:tailEnd type="none" w="med" len="med"/>
+                    </a:lnL>
+                    <a:lnR w="6350" cap="flat" cmpd="sng" algn="ctr">
+                      <a:solidFill>
+                        <a:srgbClr val="D8DEE8"/>
+                      </a:solidFill>
+                      <a:prstDash val="solid"/>
+                      <a:round/>
+                      <a:headEnd type="none" w="med" len="med"/>
+                      <a:tailEnd type="none" w="med" len="med"/>
+                    </a:lnR>
+                    <a:lnT w="6350" cap="flat" cmpd="sng" algn="ctr">
+                      <a:solidFill>
+                        <a:srgbClr val="D8DEE8"/>
+                      </a:solidFill>
+                      <a:prstDash val="solid"/>
+                      <a:round/>
+                      <a:headEnd type="none" w="med" len="med"/>
+                      <a:tailEnd type="none" w="med" len="med"/>
+                    </a:lnT>
+                    <a:lnB w="6350" cap="flat" cmpd="sng" algn="ctr">
+                      <a:solidFill>
+                        <a:srgbClr val="D8DEE8"/>
+                      </a:solidFill>
+                      <a:prstDash val="solid"/>
+                      <a:round/>
+                      <a:headEnd type="none" w="med" len="med"/>
+                      <a:tailEnd type="none" w="med" len="med"/>
+                    </a:lnB>
+                    <a:solidFill>
+                      <a:srgbClr val="FBF9F6"/>
+                    </a:solidFill>
+                  </a:tcPr>
+                </a:tc>
+              </a:tr>
+              <a:tr h="548640">
+                <a:tc>
+                  <a:txBody>
+                    <a:bodyPr/>
+                    <a:lstStyle/>
+                    <a:p>
+                      <a:pPr indent="0" marL="0">
+                        <a:buNone/>
+                      </a:pPr>
+                      <a:r>
+                        <a:rPr lang="en-US" sz="1100" b="1" dirty="0">
+                          <a:solidFill>
+                            <a:srgbClr val="2B211F"/>
+                          </a:solidFill>
+                          <a:latin typeface="Microsoft YaHei" pitchFamily="34" charset="0"/>
+                          <a:ea typeface="Microsoft YaHei" pitchFamily="34" charset="-122"/>
+                          <a:cs typeface="Microsoft YaHei" pitchFamily="34" charset="-120"/>
+                        </a:rPr>
+                        <a:t>销售员007</a:t>
                       </a:r>
                       <a:endParaRPr lang="en-US" sz="1100" dirty="0">
                         <a:latin typeface="Microsoft YaHei" charset="0"/>
@@ -4376,13 +4967,13 @@
                       <a:r>
                         <a:rPr lang="en-US" sz="1100" dirty="0">
                           <a:solidFill>
-                            <a:srgbClr val="1F2A27"/>
+                            <a:srgbClr val="2B211F"/>
                           </a:solidFill>
                           <a:latin typeface="Microsoft YaHei" pitchFamily="34" charset="0"/>
                           <a:ea typeface="Microsoft YaHei" pitchFamily="34" charset="-122"/>
                           <a:cs typeface="Microsoft YaHei" pitchFamily="34" charset="-120"/>
                         </a:rPr>
-                        <a:t>8850.5</a:t>
+                        <a:t>59846</a:t>
                       </a:r>
                       <a:endParaRPr lang="en-US" sz="1100" dirty="0">
                         <a:latin typeface="Microsoft YaHei" charset="0"/>
@@ -4444,625 +5035,7 @@
                       <a:r>
                         <a:rPr lang="en-US" sz="1100" dirty="0">
                           <a:solidFill>
-                            <a:srgbClr val="1F2A27"/>
-                          </a:solidFill>
-                          <a:latin typeface="Microsoft YaHei" pitchFamily="34" charset="0"/>
-                          <a:ea typeface="Microsoft YaHei" pitchFamily="34" charset="-122"/>
-                          <a:cs typeface="Microsoft YaHei" pitchFamily="34" charset="-120"/>
-                        </a:rPr>
-                        <a:t>7142</a:t>
-                      </a:r>
-                      <a:endParaRPr lang="en-US" sz="1100" dirty="0">
-                        <a:latin typeface="Microsoft YaHei" charset="0"/>
-                        <a:ea typeface="Microsoft YaHei" charset="0"/>
-                        <a:cs typeface="Microsoft YaHei" charset="0"/>
-                      </a:endParaRPr>
-                    </a:p>
-                  </a:txBody>
-                  <a:tcPr marL="38100" marR="38100" marT="38100" marB="38100">
-                    <a:lnL w="6350" cap="flat" cmpd="sng" algn="ctr">
-                      <a:solidFill>
-                        <a:srgbClr val="D8DEE8"/>
-                      </a:solidFill>
-                      <a:prstDash val="solid"/>
-                      <a:round/>
-                      <a:headEnd type="none" w="med" len="med"/>
-                      <a:tailEnd type="none" w="med" len="med"/>
-                    </a:lnL>
-                    <a:lnR w="6350" cap="flat" cmpd="sng" algn="ctr">
-                      <a:solidFill>
-                        <a:srgbClr val="D8DEE8"/>
-                      </a:solidFill>
-                      <a:prstDash val="solid"/>
-                      <a:round/>
-                      <a:headEnd type="none" w="med" len="med"/>
-                      <a:tailEnd type="none" w="med" len="med"/>
-                    </a:lnR>
-                    <a:lnT w="6350" cap="flat" cmpd="sng" algn="ctr">
-                      <a:solidFill>
-                        <a:srgbClr val="D8DEE8"/>
-                      </a:solidFill>
-                      <a:prstDash val="solid"/>
-                      <a:round/>
-                      <a:headEnd type="none" w="med" len="med"/>
-                      <a:tailEnd type="none" w="med" len="med"/>
-                    </a:lnT>
-                    <a:lnB w="6350" cap="flat" cmpd="sng" algn="ctr">
-                      <a:solidFill>
-                        <a:srgbClr val="D8DEE8"/>
-                      </a:solidFill>
-                      <a:prstDash val="solid"/>
-                      <a:round/>
-                      <a:headEnd type="none" w="med" len="med"/>
-                      <a:tailEnd type="none" w="med" len="med"/>
-                    </a:lnB>
-                    <a:solidFill>
-                      <a:srgbClr val="FFFFFF"/>
-                    </a:solidFill>
-                  </a:tcPr>
-                </a:tc>
-              </a:tr>
-              <a:tr h="548640">
-                <a:tc>
-                  <a:txBody>
-                    <a:bodyPr/>
-                    <a:lstStyle/>
-                    <a:p>
-                      <a:pPr indent="0" marL="0">
-                        <a:buNone/>
-                      </a:pPr>
-                      <a:r>
-                        <a:rPr lang="en-US" sz="1100" dirty="0">
-                          <a:solidFill>
-                            <a:srgbClr val="1F2A27"/>
-                          </a:solidFill>
-                          <a:latin typeface="Microsoft YaHei" pitchFamily="34" charset="0"/>
-                          <a:ea typeface="Microsoft YaHei" pitchFamily="34" charset="-122"/>
-                          <a:cs typeface="Microsoft YaHei" pitchFamily="34" charset="-120"/>
-                        </a:rPr>
-                        <a:t>销售员006</a:t>
-                      </a:r>
-                      <a:endParaRPr lang="en-US" sz="1100" dirty="0">
-                        <a:latin typeface="Microsoft YaHei" charset="0"/>
-                        <a:ea typeface="Microsoft YaHei" charset="0"/>
-                        <a:cs typeface="Microsoft YaHei" charset="0"/>
-                      </a:endParaRPr>
-                    </a:p>
-                  </a:txBody>
-                  <a:tcPr marL="38100" marR="38100" marT="38100" marB="38100">
-                    <a:lnL w="6350" cap="flat" cmpd="sng" algn="ctr">
-                      <a:solidFill>
-                        <a:srgbClr val="D8DEE8"/>
-                      </a:solidFill>
-                      <a:prstDash val="solid"/>
-                      <a:round/>
-                      <a:headEnd type="none" w="med" len="med"/>
-                      <a:tailEnd type="none" w="med" len="med"/>
-                    </a:lnL>
-                    <a:lnR w="6350" cap="flat" cmpd="sng" algn="ctr">
-                      <a:solidFill>
-                        <a:srgbClr val="D8DEE8"/>
-                      </a:solidFill>
-                      <a:prstDash val="solid"/>
-                      <a:round/>
-                      <a:headEnd type="none" w="med" len="med"/>
-                      <a:tailEnd type="none" w="med" len="med"/>
-                    </a:lnR>
-                    <a:lnT w="6350" cap="flat" cmpd="sng" algn="ctr">
-                      <a:solidFill>
-                        <a:srgbClr val="D8DEE8"/>
-                      </a:solidFill>
-                      <a:prstDash val="solid"/>
-                      <a:round/>
-                      <a:headEnd type="none" w="med" len="med"/>
-                      <a:tailEnd type="none" w="med" len="med"/>
-                    </a:lnT>
-                    <a:lnB w="6350" cap="flat" cmpd="sng" algn="ctr">
-                      <a:solidFill>
-                        <a:srgbClr val="D8DEE8"/>
-                      </a:solidFill>
-                      <a:prstDash val="solid"/>
-                      <a:round/>
-                      <a:headEnd type="none" w="med" len="med"/>
-                      <a:tailEnd type="none" w="med" len="med"/>
-                    </a:lnB>
-                    <a:solidFill>
-                      <a:srgbClr val="FFFFFF"/>
-                    </a:solidFill>
-                  </a:tcPr>
-                </a:tc>
-                <a:tc>
-                  <a:txBody>
-                    <a:bodyPr/>
-                    <a:lstStyle/>
-                    <a:p>
-                      <a:pPr indent="0" marL="0">
-                        <a:buNone/>
-                      </a:pPr>
-                      <a:r>
-                        <a:rPr lang="en-US" sz="1100" dirty="0">
-                          <a:solidFill>
-                            <a:srgbClr val="1F2A27"/>
-                          </a:solidFill>
-                          <a:latin typeface="Microsoft YaHei" pitchFamily="34" charset="0"/>
-                          <a:ea typeface="Microsoft YaHei" pitchFamily="34" charset="-122"/>
-                          <a:cs typeface="Microsoft YaHei" pitchFamily="34" charset="-120"/>
-                        </a:rPr>
-                        <a:t>13438.2</a:t>
-                      </a:r>
-                      <a:endParaRPr lang="en-US" sz="1100" dirty="0">
-                        <a:latin typeface="Microsoft YaHei" charset="0"/>
-                        <a:ea typeface="Microsoft YaHei" charset="0"/>
-                        <a:cs typeface="Microsoft YaHei" charset="0"/>
-                      </a:endParaRPr>
-                    </a:p>
-                  </a:txBody>
-                  <a:tcPr marL="38100" marR="38100" marT="38100" marB="38100">
-                    <a:lnL w="6350" cap="flat" cmpd="sng" algn="ctr">
-                      <a:solidFill>
-                        <a:srgbClr val="D8DEE8"/>
-                      </a:solidFill>
-                      <a:prstDash val="solid"/>
-                      <a:round/>
-                      <a:headEnd type="none" w="med" len="med"/>
-                      <a:tailEnd type="none" w="med" len="med"/>
-                    </a:lnL>
-                    <a:lnR w="6350" cap="flat" cmpd="sng" algn="ctr">
-                      <a:solidFill>
-                        <a:srgbClr val="D8DEE8"/>
-                      </a:solidFill>
-                      <a:prstDash val="solid"/>
-                      <a:round/>
-                      <a:headEnd type="none" w="med" len="med"/>
-                      <a:tailEnd type="none" w="med" len="med"/>
-                    </a:lnR>
-                    <a:lnT w="6350" cap="flat" cmpd="sng" algn="ctr">
-                      <a:solidFill>
-                        <a:srgbClr val="D8DEE8"/>
-                      </a:solidFill>
-                      <a:prstDash val="solid"/>
-                      <a:round/>
-                      <a:headEnd type="none" w="med" len="med"/>
-                      <a:tailEnd type="none" w="med" len="med"/>
-                    </a:lnT>
-                    <a:lnB w="6350" cap="flat" cmpd="sng" algn="ctr">
-                      <a:solidFill>
-                        <a:srgbClr val="D8DEE8"/>
-                      </a:solidFill>
-                      <a:prstDash val="solid"/>
-                      <a:round/>
-                      <a:headEnd type="none" w="med" len="med"/>
-                      <a:tailEnd type="none" w="med" len="med"/>
-                    </a:lnB>
-                    <a:solidFill>
-                      <a:srgbClr val="FFFFFF"/>
-                    </a:solidFill>
-                  </a:tcPr>
-                </a:tc>
-                <a:tc>
-                  <a:txBody>
-                    <a:bodyPr/>
-                    <a:lstStyle/>
-                    <a:p>
-                      <a:pPr indent="0" marL="0">
-                        <a:buNone/>
-                      </a:pPr>
-                      <a:r>
-                        <a:rPr lang="en-US" sz="1100" dirty="0">
-                          <a:solidFill>
-                            <a:srgbClr val="1F2A27"/>
-                          </a:solidFill>
-                          <a:latin typeface="Microsoft YaHei" pitchFamily="34" charset="0"/>
-                          <a:ea typeface="Microsoft YaHei" pitchFamily="34" charset="-122"/>
-                          <a:cs typeface="Microsoft YaHei" pitchFamily="34" charset="-120"/>
-                        </a:rPr>
-                        <a:t>11588.8</a:t>
-                      </a:r>
-                      <a:endParaRPr lang="en-US" sz="1100" dirty="0">
-                        <a:latin typeface="Microsoft YaHei" charset="0"/>
-                        <a:ea typeface="Microsoft YaHei" charset="0"/>
-                        <a:cs typeface="Microsoft YaHei" charset="0"/>
-                      </a:endParaRPr>
-                    </a:p>
-                  </a:txBody>
-                  <a:tcPr marL="38100" marR="38100" marT="38100" marB="38100">
-                    <a:lnL w="6350" cap="flat" cmpd="sng" algn="ctr">
-                      <a:solidFill>
-                        <a:srgbClr val="D8DEE8"/>
-                      </a:solidFill>
-                      <a:prstDash val="solid"/>
-                      <a:round/>
-                      <a:headEnd type="none" w="med" len="med"/>
-                      <a:tailEnd type="none" w="med" len="med"/>
-                    </a:lnL>
-                    <a:lnR w="6350" cap="flat" cmpd="sng" algn="ctr">
-                      <a:solidFill>
-                        <a:srgbClr val="D8DEE8"/>
-                      </a:solidFill>
-                      <a:prstDash val="solid"/>
-                      <a:round/>
-                      <a:headEnd type="none" w="med" len="med"/>
-                      <a:tailEnd type="none" w="med" len="med"/>
-                    </a:lnR>
-                    <a:lnT w="6350" cap="flat" cmpd="sng" algn="ctr">
-                      <a:solidFill>
-                        <a:srgbClr val="D8DEE8"/>
-                      </a:solidFill>
-                      <a:prstDash val="solid"/>
-                      <a:round/>
-                      <a:headEnd type="none" w="med" len="med"/>
-                      <a:tailEnd type="none" w="med" len="med"/>
-                    </a:lnT>
-                    <a:lnB w="6350" cap="flat" cmpd="sng" algn="ctr">
-                      <a:solidFill>
-                        <a:srgbClr val="D8DEE8"/>
-                      </a:solidFill>
-                      <a:prstDash val="solid"/>
-                      <a:round/>
-                      <a:headEnd type="none" w="med" len="med"/>
-                      <a:tailEnd type="none" w="med" len="med"/>
-                    </a:lnB>
-                    <a:solidFill>
-                      <a:srgbClr val="FFFFFF"/>
-                    </a:solidFill>
-                  </a:tcPr>
-                </a:tc>
-              </a:tr>
-              <a:tr h="548640">
-                <a:tc>
-                  <a:txBody>
-                    <a:bodyPr/>
-                    <a:lstStyle/>
-                    <a:p>
-                      <a:pPr indent="0" marL="0">
-                        <a:buNone/>
-                      </a:pPr>
-                      <a:r>
-                        <a:rPr lang="en-US" sz="1100" dirty="0">
-                          <a:solidFill>
-                            <a:srgbClr val="1F2A27"/>
-                          </a:solidFill>
-                          <a:latin typeface="Microsoft YaHei" pitchFamily="34" charset="0"/>
-                          <a:ea typeface="Microsoft YaHei" pitchFamily="34" charset="-122"/>
-                          <a:cs typeface="Microsoft YaHei" pitchFamily="34" charset="-120"/>
-                        </a:rPr>
-                        <a:t>销售员005</a:t>
-                      </a:r>
-                      <a:endParaRPr lang="en-US" sz="1100" dirty="0">
-                        <a:latin typeface="Microsoft YaHei" charset="0"/>
-                        <a:ea typeface="Microsoft YaHei" charset="0"/>
-                        <a:cs typeface="Microsoft YaHei" charset="0"/>
-                      </a:endParaRPr>
-                    </a:p>
-                  </a:txBody>
-                  <a:tcPr marL="38100" marR="38100" marT="38100" marB="38100">
-                    <a:lnL w="6350" cap="flat" cmpd="sng" algn="ctr">
-                      <a:solidFill>
-                        <a:srgbClr val="D8DEE8"/>
-                      </a:solidFill>
-                      <a:prstDash val="solid"/>
-                      <a:round/>
-                      <a:headEnd type="none" w="med" len="med"/>
-                      <a:tailEnd type="none" w="med" len="med"/>
-                    </a:lnL>
-                    <a:lnR w="6350" cap="flat" cmpd="sng" algn="ctr">
-                      <a:solidFill>
-                        <a:srgbClr val="D8DEE8"/>
-                      </a:solidFill>
-                      <a:prstDash val="solid"/>
-                      <a:round/>
-                      <a:headEnd type="none" w="med" len="med"/>
-                      <a:tailEnd type="none" w="med" len="med"/>
-                    </a:lnR>
-                    <a:lnT w="6350" cap="flat" cmpd="sng" algn="ctr">
-                      <a:solidFill>
-                        <a:srgbClr val="D8DEE8"/>
-                      </a:solidFill>
-                      <a:prstDash val="solid"/>
-                      <a:round/>
-                      <a:headEnd type="none" w="med" len="med"/>
-                      <a:tailEnd type="none" w="med" len="med"/>
-                    </a:lnT>
-                    <a:lnB w="6350" cap="flat" cmpd="sng" algn="ctr">
-                      <a:solidFill>
-                        <a:srgbClr val="D8DEE8"/>
-                      </a:solidFill>
-                      <a:prstDash val="solid"/>
-                      <a:round/>
-                      <a:headEnd type="none" w="med" len="med"/>
-                      <a:tailEnd type="none" w="med" len="med"/>
-                    </a:lnB>
-                    <a:solidFill>
-                      <a:srgbClr val="FFFFFF"/>
-                    </a:solidFill>
-                  </a:tcPr>
-                </a:tc>
-                <a:tc>
-                  <a:txBody>
-                    <a:bodyPr/>
-                    <a:lstStyle/>
-                    <a:p>
-                      <a:pPr indent="0" marL="0">
-                        <a:buNone/>
-                      </a:pPr>
-                      <a:r>
-                        <a:rPr lang="en-US" sz="1100" dirty="0">
-                          <a:solidFill>
-                            <a:srgbClr val="1F2A27"/>
-                          </a:solidFill>
-                          <a:latin typeface="Microsoft YaHei" pitchFamily="34" charset="0"/>
-                          <a:ea typeface="Microsoft YaHei" pitchFamily="34" charset="-122"/>
-                          <a:cs typeface="Microsoft YaHei" pitchFamily="34" charset="-120"/>
-                        </a:rPr>
-                        <a:t>16700.8</a:t>
-                      </a:r>
-                      <a:endParaRPr lang="en-US" sz="1100" dirty="0">
-                        <a:latin typeface="Microsoft YaHei" charset="0"/>
-                        <a:ea typeface="Microsoft YaHei" charset="0"/>
-                        <a:cs typeface="Microsoft YaHei" charset="0"/>
-                      </a:endParaRPr>
-                    </a:p>
-                  </a:txBody>
-                  <a:tcPr marL="38100" marR="38100" marT="38100" marB="38100">
-                    <a:lnL w="6350" cap="flat" cmpd="sng" algn="ctr">
-                      <a:solidFill>
-                        <a:srgbClr val="D8DEE8"/>
-                      </a:solidFill>
-                      <a:prstDash val="solid"/>
-                      <a:round/>
-                      <a:headEnd type="none" w="med" len="med"/>
-                      <a:tailEnd type="none" w="med" len="med"/>
-                    </a:lnL>
-                    <a:lnR w="6350" cap="flat" cmpd="sng" algn="ctr">
-                      <a:solidFill>
-                        <a:srgbClr val="D8DEE8"/>
-                      </a:solidFill>
-                      <a:prstDash val="solid"/>
-                      <a:round/>
-                      <a:headEnd type="none" w="med" len="med"/>
-                      <a:tailEnd type="none" w="med" len="med"/>
-                    </a:lnR>
-                    <a:lnT w="6350" cap="flat" cmpd="sng" algn="ctr">
-                      <a:solidFill>
-                        <a:srgbClr val="D8DEE8"/>
-                      </a:solidFill>
-                      <a:prstDash val="solid"/>
-                      <a:round/>
-                      <a:headEnd type="none" w="med" len="med"/>
-                      <a:tailEnd type="none" w="med" len="med"/>
-                    </a:lnT>
-                    <a:lnB w="6350" cap="flat" cmpd="sng" algn="ctr">
-                      <a:solidFill>
-                        <a:srgbClr val="D8DEE8"/>
-                      </a:solidFill>
-                      <a:prstDash val="solid"/>
-                      <a:round/>
-                      <a:headEnd type="none" w="med" len="med"/>
-                      <a:tailEnd type="none" w="med" len="med"/>
-                    </a:lnB>
-                    <a:solidFill>
-                      <a:srgbClr val="FFFFFF"/>
-                    </a:solidFill>
-                  </a:tcPr>
-                </a:tc>
-                <a:tc>
-                  <a:txBody>
-                    <a:bodyPr/>
-                    <a:lstStyle/>
-                    <a:p>
-                      <a:pPr indent="0" marL="0">
-                        <a:buNone/>
-                      </a:pPr>
-                      <a:r>
-                        <a:rPr lang="en-US" sz="1100" dirty="0">
-                          <a:solidFill>
-                            <a:srgbClr val="1F2A27"/>
-                          </a:solidFill>
-                          <a:latin typeface="Microsoft YaHei" pitchFamily="34" charset="0"/>
-                          <a:ea typeface="Microsoft YaHei" pitchFamily="34" charset="-122"/>
-                          <a:cs typeface="Microsoft YaHei" pitchFamily="34" charset="-120"/>
-                        </a:rPr>
-                        <a:t>12610.5</a:t>
-                      </a:r>
-                      <a:endParaRPr lang="en-US" sz="1100" dirty="0">
-                        <a:latin typeface="Microsoft YaHei" charset="0"/>
-                        <a:ea typeface="Microsoft YaHei" charset="0"/>
-                        <a:cs typeface="Microsoft YaHei" charset="0"/>
-                      </a:endParaRPr>
-                    </a:p>
-                  </a:txBody>
-                  <a:tcPr marL="38100" marR="38100" marT="38100" marB="38100">
-                    <a:lnL w="6350" cap="flat" cmpd="sng" algn="ctr">
-                      <a:solidFill>
-                        <a:srgbClr val="D8DEE8"/>
-                      </a:solidFill>
-                      <a:prstDash val="solid"/>
-                      <a:round/>
-                      <a:headEnd type="none" w="med" len="med"/>
-                      <a:tailEnd type="none" w="med" len="med"/>
-                    </a:lnL>
-                    <a:lnR w="6350" cap="flat" cmpd="sng" algn="ctr">
-                      <a:solidFill>
-                        <a:srgbClr val="D8DEE8"/>
-                      </a:solidFill>
-                      <a:prstDash val="solid"/>
-                      <a:round/>
-                      <a:headEnd type="none" w="med" len="med"/>
-                      <a:tailEnd type="none" w="med" len="med"/>
-                    </a:lnR>
-                    <a:lnT w="6350" cap="flat" cmpd="sng" algn="ctr">
-                      <a:solidFill>
-                        <a:srgbClr val="D8DEE8"/>
-                      </a:solidFill>
-                      <a:prstDash val="solid"/>
-                      <a:round/>
-                      <a:headEnd type="none" w="med" len="med"/>
-                      <a:tailEnd type="none" w="med" len="med"/>
-                    </a:lnT>
-                    <a:lnB w="6350" cap="flat" cmpd="sng" algn="ctr">
-                      <a:solidFill>
-                        <a:srgbClr val="D8DEE8"/>
-                      </a:solidFill>
-                      <a:prstDash val="solid"/>
-                      <a:round/>
-                      <a:headEnd type="none" w="med" len="med"/>
-                      <a:tailEnd type="none" w="med" len="med"/>
-                    </a:lnB>
-                    <a:solidFill>
-                      <a:srgbClr val="FFFFFF"/>
-                    </a:solidFill>
-                  </a:tcPr>
-                </a:tc>
-              </a:tr>
-              <a:tr h="548640">
-                <a:tc>
-                  <a:txBody>
-                    <a:bodyPr/>
-                    <a:lstStyle/>
-                    <a:p>
-                      <a:pPr indent="0" marL="0">
-                        <a:buNone/>
-                      </a:pPr>
-                      <a:r>
-                        <a:rPr lang="en-US" sz="1100" dirty="0">
-                          <a:solidFill>
-                            <a:srgbClr val="1F2A27"/>
-                          </a:solidFill>
-                          <a:latin typeface="Microsoft YaHei" pitchFamily="34" charset="0"/>
-                          <a:ea typeface="Microsoft YaHei" pitchFamily="34" charset="-122"/>
-                          <a:cs typeface="Microsoft YaHei" pitchFamily="34" charset="-120"/>
-                        </a:rPr>
-                        <a:t>销售员007</a:t>
-                      </a:r>
-                      <a:endParaRPr lang="en-US" sz="1100" dirty="0">
-                        <a:latin typeface="Microsoft YaHei" charset="0"/>
-                        <a:ea typeface="Microsoft YaHei" charset="0"/>
-                        <a:cs typeface="Microsoft YaHei" charset="0"/>
-                      </a:endParaRPr>
-                    </a:p>
-                  </a:txBody>
-                  <a:tcPr marL="38100" marR="38100" marT="38100" marB="38100">
-                    <a:lnL w="6350" cap="flat" cmpd="sng" algn="ctr">
-                      <a:solidFill>
-                        <a:srgbClr val="D8DEE8"/>
-                      </a:solidFill>
-                      <a:prstDash val="solid"/>
-                      <a:round/>
-                      <a:headEnd type="none" w="med" len="med"/>
-                      <a:tailEnd type="none" w="med" len="med"/>
-                    </a:lnL>
-                    <a:lnR w="6350" cap="flat" cmpd="sng" algn="ctr">
-                      <a:solidFill>
-                        <a:srgbClr val="D8DEE8"/>
-                      </a:solidFill>
-                      <a:prstDash val="solid"/>
-                      <a:round/>
-                      <a:headEnd type="none" w="med" len="med"/>
-                      <a:tailEnd type="none" w="med" len="med"/>
-                    </a:lnR>
-                    <a:lnT w="6350" cap="flat" cmpd="sng" algn="ctr">
-                      <a:solidFill>
-                        <a:srgbClr val="D8DEE8"/>
-                      </a:solidFill>
-                      <a:prstDash val="solid"/>
-                      <a:round/>
-                      <a:headEnd type="none" w="med" len="med"/>
-                      <a:tailEnd type="none" w="med" len="med"/>
-                    </a:lnT>
-                    <a:lnB w="6350" cap="flat" cmpd="sng" algn="ctr">
-                      <a:solidFill>
-                        <a:srgbClr val="D8DEE8"/>
-                      </a:solidFill>
-                      <a:prstDash val="solid"/>
-                      <a:round/>
-                      <a:headEnd type="none" w="med" len="med"/>
-                      <a:tailEnd type="none" w="med" len="med"/>
-                    </a:lnB>
-                    <a:solidFill>
-                      <a:srgbClr val="FFFFFF"/>
-                    </a:solidFill>
-                  </a:tcPr>
-                </a:tc>
-                <a:tc>
-                  <a:txBody>
-                    <a:bodyPr/>
-                    <a:lstStyle/>
-                    <a:p>
-                      <a:pPr indent="0" marL="0">
-                        <a:buNone/>
-                      </a:pPr>
-                      <a:r>
-                        <a:rPr lang="en-US" sz="1100" dirty="0">
-                          <a:solidFill>
-                            <a:srgbClr val="1F2A27"/>
-                          </a:solidFill>
-                          <a:latin typeface="Microsoft YaHei" pitchFamily="34" charset="0"/>
-                          <a:ea typeface="Microsoft YaHei" pitchFamily="34" charset="-122"/>
-                          <a:cs typeface="Microsoft YaHei" pitchFamily="34" charset="-120"/>
-                        </a:rPr>
-                        <a:t>59846</a:t>
-                      </a:r>
-                      <a:endParaRPr lang="en-US" sz="1100" dirty="0">
-                        <a:latin typeface="Microsoft YaHei" charset="0"/>
-                        <a:ea typeface="Microsoft YaHei" charset="0"/>
-                        <a:cs typeface="Microsoft YaHei" charset="0"/>
-                      </a:endParaRPr>
-                    </a:p>
-                  </a:txBody>
-                  <a:tcPr marL="38100" marR="38100" marT="38100" marB="38100">
-                    <a:lnL w="6350" cap="flat" cmpd="sng" algn="ctr">
-                      <a:solidFill>
-                        <a:srgbClr val="D8DEE8"/>
-                      </a:solidFill>
-                      <a:prstDash val="solid"/>
-                      <a:round/>
-                      <a:headEnd type="none" w="med" len="med"/>
-                      <a:tailEnd type="none" w="med" len="med"/>
-                    </a:lnL>
-                    <a:lnR w="6350" cap="flat" cmpd="sng" algn="ctr">
-                      <a:solidFill>
-                        <a:srgbClr val="D8DEE8"/>
-                      </a:solidFill>
-                      <a:prstDash val="solid"/>
-                      <a:round/>
-                      <a:headEnd type="none" w="med" len="med"/>
-                      <a:tailEnd type="none" w="med" len="med"/>
-                    </a:lnR>
-                    <a:lnT w="6350" cap="flat" cmpd="sng" algn="ctr">
-                      <a:solidFill>
-                        <a:srgbClr val="D8DEE8"/>
-                      </a:solidFill>
-                      <a:prstDash val="solid"/>
-                      <a:round/>
-                      <a:headEnd type="none" w="med" len="med"/>
-                      <a:tailEnd type="none" w="med" len="med"/>
-                    </a:lnT>
-                    <a:lnB w="6350" cap="flat" cmpd="sng" algn="ctr">
-                      <a:solidFill>
-                        <a:srgbClr val="D8DEE8"/>
-                      </a:solidFill>
-                      <a:prstDash val="solid"/>
-                      <a:round/>
-                      <a:headEnd type="none" w="med" len="med"/>
-                      <a:tailEnd type="none" w="med" len="med"/>
-                    </a:lnB>
-                    <a:solidFill>
-                      <a:srgbClr val="FFFFFF"/>
-                    </a:solidFill>
-                  </a:tcPr>
-                </a:tc>
-                <a:tc>
-                  <a:txBody>
-                    <a:bodyPr/>
-                    <a:lstStyle/>
-                    <a:p>
-                      <a:pPr indent="0" marL="0">
-                        <a:buNone/>
-                      </a:pPr>
-                      <a:r>
-                        <a:rPr lang="en-US" sz="1100" dirty="0">
-                          <a:solidFill>
-                            <a:srgbClr val="1F2A27"/>
+                            <a:srgbClr val="2B211F"/>
                           </a:solidFill>
                           <a:latin typeface="Microsoft YaHei" pitchFamily="34" charset="0"/>
                           <a:ea typeface="Microsoft YaHei" pitchFamily="34" charset="-122"/>
@@ -5142,7 +5115,9 @@
           <a:ln/>
         </p:spPr>
         <p:txBody>
-          <a:bodyPr wrap="square" lIns="0" tIns="0" rIns="0" bIns="0" rtlCol="0" anchor="ctr"/>
+          <a:bodyPr wrap="square" lIns="0" tIns="0" rIns="0" bIns="0" rtlCol="0" anchor="ctr">
+            <a:normAutofit/>
+          </a:bodyPr>
           <a:lstStyle/>
           <a:p>
             <a:pPr indent="0" marL="0">
@@ -5151,30 +5126,13 @@
             <a:r>
               <a:rPr lang="en-US" sz="800" dirty="0">
                 <a:solidFill>
-                  <a:srgbClr val="6D7D77"/>
+                  <a:srgbClr val="7D6C68"/>
                 </a:solidFill>
                 <a:latin typeface="Microsoft YaHei" pitchFamily="34" charset="0"/>
                 <a:ea typeface="Microsoft YaHei" pitchFamily="34" charset="-122"/>
                 <a:cs typeface="Microsoft YaHei" pitchFamily="34" charset="-120"/>
               </a:rPr>
               <a:t>数据来源</a:t>
-            </a:r>
-            <a:endParaRPr lang="en-US" sz="800" dirty="0"/>
-          </a:p>
-          <a:p>
-            <a:pPr indent="0" marL="0">
-              <a:buNone/>
-            </a:pPr>
-            <a:r>
-              <a:rPr lang="en-US" sz="800" dirty="0">
-                <a:solidFill>
-                  <a:srgbClr val="6D7D77"/>
-                </a:solidFill>
-                <a:latin typeface="Microsoft YaHei" pitchFamily="34" charset="0"/>
-                <a:ea typeface="Microsoft YaHei" pitchFamily="34" charset="-122"/>
-                <a:cs typeface="Microsoft YaHei" pitchFamily="34" charset="-120"/>
-              </a:rPr>
-              <a:t>[Evidence: ev-pilot-current-total, ev-pilot-prior-total, ev-pilot-performance]</a:t>
             </a:r>
             <a:endParaRPr lang="en-US" sz="800" dirty="0"/>
           </a:p>
@@ -5240,7 +5198,7 @@
             <a:lvl1pPr>
               <a:defRPr sz="900">
                 <a:solidFill>
-                  <a:srgbClr val="6D7D77"/>
+                  <a:srgbClr val="7D6C68"/>
                 </a:solidFill>
                 <a:latin typeface="Microsoft YaHei"/>
                 <a:ea typeface="Microsoft YaHei"/>
@@ -5312,7 +5270,7 @@
             <a:r>
               <a:rPr lang="en-US" sz="3000" b="1" dirty="0">
                 <a:solidFill>
-                  <a:srgbClr val="24443A"/>
+                  <a:srgbClr val="8B1E1E"/>
                 </a:solidFill>
                 <a:latin typeface="Microsoft YaHei" pitchFamily="34" charset="0"/>
                 <a:ea typeface="Microsoft YaHei" pitchFamily="34" charset="-122"/>
@@ -5342,7 +5300,9 @@
           <a:ln/>
         </p:spPr>
         <p:txBody>
-          <a:bodyPr wrap="square" lIns="50800" tIns="50800" rIns="50800" bIns="50800" rtlCol="0" anchor="t"/>
+          <a:bodyPr wrap="square" lIns="50800" tIns="50800" rIns="50800" bIns="50800" rtlCol="0" anchor="t">
+            <a:normAutofit/>
+          </a:bodyPr>
           <a:lstStyle/>
           <a:p>
             <a:pPr indent="0" marL="0">
@@ -5351,30 +5311,13 @@
             <a:r>
               <a:rPr lang="en-US" sz="1800" dirty="0">
                 <a:solidFill>
-                  <a:srgbClr val="1F2A27"/>
+                  <a:srgbClr val="2B211F"/>
                 </a:solidFill>
                 <a:latin typeface="Microsoft YaHei" pitchFamily="34" charset="0"/>
                 <a:ea typeface="Microsoft YaHei" pitchFamily="34" charset="-122"/>
                 <a:cs typeface="Microsoft YaHei" pitchFamily="34" charset="-120"/>
               </a:rPr>
               <a:t>保持月度复盘，优先跟踪完成率与同比偏差；补充样本前不扩大质量结论。</a:t>
-            </a:r>
-            <a:endParaRPr lang="en-US" sz="1800" dirty="0"/>
-          </a:p>
-          <a:p>
-            <a:pPr indent="0" marL="0">
-              <a:buNone/>
-            </a:pPr>
-            <a:r>
-              <a:rPr lang="en-US" sz="1800" dirty="0">
-                <a:solidFill>
-                  <a:srgbClr val="1F2A27"/>
-                </a:solidFill>
-                <a:latin typeface="Microsoft YaHei" pitchFamily="34" charset="0"/>
-                <a:ea typeface="Microsoft YaHei" pitchFamily="34" charset="-122"/>
-                <a:cs typeface="Microsoft YaHei" pitchFamily="34" charset="-120"/>
-              </a:rPr>
-              <a:t>[Evidence: ev-pilot-performance]</a:t>
             </a:r>
             <a:endParaRPr lang="en-US" sz="1800" dirty="0"/>
           </a:p>
@@ -5398,7 +5341,9 @@
           <a:ln/>
         </p:spPr>
         <p:txBody>
-          <a:bodyPr wrap="square" lIns="0" tIns="0" rIns="0" bIns="0" rtlCol="0" anchor="ctr"/>
+          <a:bodyPr wrap="square" lIns="0" tIns="0" rIns="0" bIns="0" rtlCol="0" anchor="ctr">
+            <a:normAutofit/>
+          </a:bodyPr>
           <a:lstStyle/>
           <a:p>
             <a:pPr indent="0" marL="0">
@@ -5407,30 +5352,13 @@
             <a:r>
               <a:rPr lang="en-US" sz="800" dirty="0">
                 <a:solidFill>
-                  <a:srgbClr val="6D7D77"/>
+                  <a:srgbClr val="7D6C68"/>
                 </a:solidFill>
                 <a:latin typeface="Microsoft YaHei" pitchFamily="34" charset="0"/>
                 <a:ea typeface="Microsoft YaHei" pitchFamily="34" charset="-122"/>
                 <a:cs typeface="Microsoft YaHei" pitchFamily="34" charset="-120"/>
               </a:rPr>
               <a:t>数据来源</a:t>
-            </a:r>
-            <a:endParaRPr lang="en-US" sz="800" dirty="0"/>
-          </a:p>
-          <a:p>
-            <a:pPr indent="0" marL="0">
-              <a:buNone/>
-            </a:pPr>
-            <a:r>
-              <a:rPr lang="en-US" sz="800" dirty="0">
-                <a:solidFill>
-                  <a:srgbClr val="6D7D77"/>
-                </a:solidFill>
-                <a:latin typeface="Microsoft YaHei" pitchFamily="34" charset="0"/>
-                <a:ea typeface="Microsoft YaHei" pitchFamily="34" charset="-122"/>
-                <a:cs typeface="Microsoft YaHei" pitchFamily="34" charset="-120"/>
-              </a:rPr>
-              <a:t>[Evidence: ev-pilot-performance]</a:t>
             </a:r>
             <a:endParaRPr lang="en-US" sz="800" dirty="0"/>
           </a:p>
@@ -5496,7 +5424,7 @@
             <a:lvl1pPr>
               <a:defRPr sz="900">
                 <a:solidFill>
-                  <a:srgbClr val="6D7D77"/>
+                  <a:srgbClr val="7D6C68"/>
                 </a:solidFill>
                 <a:latin typeface="Microsoft YaHei"/>
                 <a:ea typeface="Microsoft YaHei"/>

</xml_diff>

<commit_message>
fix(presentation): autofit long closing subtitles
Retries reused a fixed subtitle box without autofit, reproducing the same quality blocker. Render subtitles with shrink autofit and guard the OOXML behavior with a regression test.
</commit_message>
<xml_diff>
--- a/golden-data/expected/sales-pilot-v1.pptx
+++ b/golden-data/expected/sales-pilot-v1.pptx
@@ -2169,7 +2169,9 @@
           <a:ln/>
         </p:spPr>
         <p:txBody>
-          <a:bodyPr wrap="square" lIns="0" tIns="0" rIns="0" bIns="0" rtlCol="0" anchor="ctr"/>
+          <a:bodyPr wrap="square" lIns="0" tIns="0" rIns="0" bIns="0" rtlCol="0" anchor="ctr">
+            <a:normAutofit/>
+          </a:bodyPr>
           <a:lstStyle/>
           <a:p>
             <a:pPr algn="ctr" indent="0" marL="0">

</xml_diff>